<commit_message>
Refresh FR data as of July 28
</commit_message>
<xml_diff>
--- a/exports/Moradabad_Division_DRM_Budget_FR_Analysis.pptx
+++ b/exports/Moradabad_Division_DRM_Budget_FR_Analysis.pptx
@@ -5902,7 +5902,7 @@
                 </a:solidFill>
                 <a:latin typeface="Times New Roman"/>
               </a:rPr>
-              <a:t>Accounts Dept | FY 2026-2027 | DRM Budget &amp; FR Analysis | Completed JUN 2026</a:t>
+              <a:t>Accounts Dept | FY 2026-2027 | DRM Budget &amp; FR Analysis | Completed JUL 2026</a:t>
             </a:r>
           </a:p>
         </p:txBody>
@@ -6216,7 +6216,7 @@
                           </a:solidFill>
                           <a:latin typeface="Times New Roman"/>
                         </a:rPr>
-                        <a:t>BP UPTO JUN 2026</a:t>
+                        <a:t>BP UPTO JUL 2026</a:t>
                       </a:r>
                     </a:p>
                   </a:txBody>
@@ -6279,7 +6279,7 @@
                           </a:solidFill>
                           <a:latin typeface="Times New Roman"/>
                         </a:rPr>
-                        <a:t>Actuals Upto JUN 2026</a:t>
+                        <a:t>Actuals Upto JUL 2026</a:t>
                       </a:r>
                     </a:p>
                   </a:txBody>
@@ -6715,7 +6715,7 @@
                           </a:solidFill>
                           <a:latin typeface="Times New Roman"/>
                         </a:rPr>
-                        <a:t>160,380</a:t>
+                        <a:t>213,841</a:t>
                       </a:r>
                       <a:br/>
                       <a:r>
@@ -6725,7 +6725,7 @@
                           </a:solidFill>
                           <a:latin typeface="Times New Roman"/>
                         </a:rPr>
-                        <a:t>Cr. 16.04</a:t>
+                        <a:t>Cr. 21.38</a:t>
                       </a:r>
                     </a:p>
                   </a:txBody>
@@ -6768,7 +6768,7 @@
                           </a:solidFill>
                           <a:latin typeface="Times New Roman"/>
                         </a:rPr>
-                        <a:t>176,884</a:t>
+                        <a:t>232,594</a:t>
                       </a:r>
                       <a:br/>
                       <a:r>
@@ -6778,7 +6778,7 @@
                           </a:solidFill>
                           <a:latin typeface="Times New Roman"/>
                         </a:rPr>
-                        <a:t>Cr. 17.69</a:t>
+                        <a:t>Cr. 23.26</a:t>
                       </a:r>
                     </a:p>
                   </a:txBody>
@@ -6821,7 +6821,7 @@
                           </a:solidFill>
                           <a:latin typeface="Times New Roman"/>
                         </a:rPr>
-                        <a:t>16,504</a:t>
+                        <a:t>18,753</a:t>
                       </a:r>
                       <a:br/>
                       <a:r>
@@ -6831,7 +6831,7 @@
                           </a:solidFill>
                           <a:latin typeface="Times New Roman"/>
                         </a:rPr>
-                        <a:t>Cr. 1.65</a:t>
+                        <a:t>Cr. 1.88</a:t>
                       </a:r>
                     </a:p>
                   </a:txBody>
@@ -6874,7 +6874,7 @@
                           </a:solidFill>
                           <a:latin typeface="Times New Roman"/>
                         </a:rPr>
-                        <a:t>110  </a:t>
+                        <a:t>109  </a:t>
                       </a:r>
                     </a:p>
                   </a:txBody>
@@ -6917,7 +6917,7 @@
                           </a:solidFill>
                           <a:latin typeface="Times New Roman"/>
                         </a:rPr>
-                        <a:t>464,638</a:t>
+                        <a:t>408,928</a:t>
                       </a:r>
                       <a:br/>
                       <a:r>
@@ -6927,7 +6927,7 @@
                           </a:solidFill>
                           <a:latin typeface="Times New Roman"/>
                         </a:rPr>
-                        <a:t>Cr. 46.46</a:t>
+                        <a:t>Cr. 40.89</a:t>
                       </a:r>
                     </a:p>
                   </a:txBody>
@@ -6970,7 +6970,7 @@
                           </a:solidFill>
                           <a:latin typeface="Times New Roman"/>
                         </a:rPr>
-                        <a:t>28  </a:t>
+                        <a:t>36  </a:t>
                       </a:r>
                     </a:p>
                   </a:txBody>
@@ -7154,7 +7154,7 @@
                           </a:solidFill>
                           <a:latin typeface="Times New Roman"/>
                         </a:rPr>
-                        <a:t>902,226</a:t>
+                        <a:t>1,202,967</a:t>
                       </a:r>
                       <a:br/>
                       <a:r>
@@ -7164,7 +7164,7 @@
                           </a:solidFill>
                           <a:latin typeface="Times New Roman"/>
                         </a:rPr>
-                        <a:t>Cr. 90.22</a:t>
+                        <a:t>Cr. 120.30</a:t>
                       </a:r>
                     </a:p>
                   </a:txBody>
@@ -7207,7 +7207,7 @@
                           </a:solidFill>
                           <a:latin typeface="Times New Roman"/>
                         </a:rPr>
-                        <a:t>1,105,970</a:t>
+                        <a:t>1,467,818</a:t>
                       </a:r>
                       <a:br/>
                       <a:r>
@@ -7217,7 +7217,7 @@
                           </a:solidFill>
                           <a:latin typeface="Times New Roman"/>
                         </a:rPr>
-                        <a:t>Cr. 110.60</a:t>
+                        <a:t>Cr. 146.78</a:t>
                       </a:r>
                     </a:p>
                   </a:txBody>
@@ -7260,7 +7260,7 @@
                           </a:solidFill>
                           <a:latin typeface="Times New Roman"/>
                         </a:rPr>
-                        <a:t>203,744</a:t>
+                        <a:t>264,851</a:t>
                       </a:r>
                       <a:br/>
                       <a:r>
@@ -7270,7 +7270,7 @@
                           </a:solidFill>
                           <a:latin typeface="Times New Roman"/>
                         </a:rPr>
-                        <a:t>Cr. 20.37</a:t>
+                        <a:t>Cr. 26.49</a:t>
                       </a:r>
                     </a:p>
                   </a:txBody>
@@ -7313,7 +7313,7 @@
                           </a:solidFill>
                           <a:latin typeface="Times New Roman"/>
                         </a:rPr>
-                        <a:t>123  </a:t>
+                        <a:t>122  </a:t>
                       </a:r>
                     </a:p>
                   </a:txBody>
@@ -7356,7 +7356,7 @@
                           </a:solidFill>
                           <a:latin typeface="Times New Roman"/>
                         </a:rPr>
-                        <a:t>2,502,932</a:t>
+                        <a:t>2,141,084</a:t>
                       </a:r>
                       <a:br/>
                       <a:r>
@@ -7366,7 +7366,7 @@
                           </a:solidFill>
                           <a:latin typeface="Times New Roman"/>
                         </a:rPr>
-                        <a:t>Cr. 250.29</a:t>
+                        <a:t>Cr. 214.11</a:t>
                       </a:r>
                     </a:p>
                   </a:txBody>
@@ -7409,7 +7409,7 @@
                           </a:solidFill>
                           <a:latin typeface="Times New Roman"/>
                         </a:rPr>
-                        <a:t>31  </a:t>
+                        <a:t>41  </a:t>
                       </a:r>
                     </a:p>
                   </a:txBody>
@@ -7593,7 +7593,7 @@
                           </a:solidFill>
                           <a:latin typeface="Times New Roman"/>
                         </a:rPr>
-                        <a:t>466,211</a:t>
+                        <a:t>621,614</a:t>
                       </a:r>
                       <a:br/>
                       <a:r>
@@ -7603,7 +7603,7 @@
                           </a:solidFill>
                           <a:latin typeface="Times New Roman"/>
                         </a:rPr>
-                        <a:t>Cr. 46.62</a:t>
+                        <a:t>Cr. 62.16</a:t>
                       </a:r>
                     </a:p>
                   </a:txBody>
@@ -7646,7 +7646,7 @@
                           </a:solidFill>
                           <a:latin typeface="Times New Roman"/>
                         </a:rPr>
-                        <a:t>273,692</a:t>
+                        <a:t>782,032</a:t>
                       </a:r>
                       <a:br/>
                       <a:r>
@@ -7656,7 +7656,7 @@
                           </a:solidFill>
                           <a:latin typeface="Times New Roman"/>
                         </a:rPr>
-                        <a:t>Cr. 27.37</a:t>
+                        <a:t>Cr. 78.20</a:t>
                       </a:r>
                     </a:p>
                   </a:txBody>
@@ -7699,7 +7699,7 @@
                           </a:solidFill>
                           <a:latin typeface="Times New Roman"/>
                         </a:rPr>
-                        <a:t>-192,519</a:t>
+                        <a:t>160,418</a:t>
                       </a:r>
                       <a:br/>
                       <a:r>
@@ -7709,7 +7709,7 @@
                           </a:solidFill>
                           <a:latin typeface="Times New Roman"/>
                         </a:rPr>
-                        <a:t>Cr. -19.25</a:t>
+                        <a:t>Cr. 16.04</a:t>
                       </a:r>
                     </a:p>
                   </a:txBody>
@@ -7752,7 +7752,7 @@
                           </a:solidFill>
                           <a:latin typeface="Times New Roman"/>
                         </a:rPr>
-                        <a:t>59  </a:t>
+                        <a:t>126  </a:t>
                       </a:r>
                     </a:p>
                   </a:txBody>
@@ -7795,7 +7795,7 @@
                           </a:solidFill>
                           <a:latin typeface="Times New Roman"/>
                         </a:rPr>
-                        <a:t>1,591,151</a:t>
+                        <a:t>1,082,811</a:t>
                       </a:r>
                       <a:br/>
                       <a:r>
@@ -7805,7 +7805,7 @@
                           </a:solidFill>
                           <a:latin typeface="Times New Roman"/>
                         </a:rPr>
-                        <a:t>Cr. 159.12</a:t>
+                        <a:t>Cr. 108.28</a:t>
                       </a:r>
                     </a:p>
                   </a:txBody>
@@ -7848,7 +7848,7 @@
                           </a:solidFill>
                           <a:latin typeface="Times New Roman"/>
                         </a:rPr>
-                        <a:t>15  </a:t>
+                        <a:t>42  </a:t>
                       </a:r>
                     </a:p>
                   </a:txBody>
@@ -8032,7 +8032,7 @@
                           </a:solidFill>
                           <a:latin typeface="Times New Roman"/>
                         </a:rPr>
-                        <a:t>338,395</a:t>
+                        <a:t>451,194</a:t>
                       </a:r>
                       <a:br/>
                       <a:r>
@@ -8042,7 +8042,7 @@
                           </a:solidFill>
                           <a:latin typeface="Times New Roman"/>
                         </a:rPr>
-                        <a:t>Cr. 33.84</a:t>
+                        <a:t>Cr. 45.12</a:t>
                       </a:r>
                     </a:p>
                   </a:txBody>
@@ -8085,7 +8085,7 @@
                           </a:solidFill>
                           <a:latin typeface="Times New Roman"/>
                         </a:rPr>
-                        <a:t>597,993</a:t>
+                        <a:t>722,606</a:t>
                       </a:r>
                       <a:br/>
                       <a:r>
@@ -8095,7 +8095,7 @@
                           </a:solidFill>
                           <a:latin typeface="Times New Roman"/>
                         </a:rPr>
-                        <a:t>Cr. 59.80</a:t>
+                        <a:t>Cr. 72.26</a:t>
                       </a:r>
                     </a:p>
                   </a:txBody>
@@ -8138,7 +8138,7 @@
                           </a:solidFill>
                           <a:latin typeface="Times New Roman"/>
                         </a:rPr>
-                        <a:t>259,598</a:t>
+                        <a:t>271,412</a:t>
                       </a:r>
                       <a:br/>
                       <a:r>
@@ -8148,7 +8148,7 @@
                           </a:solidFill>
                           <a:latin typeface="Times New Roman"/>
                         </a:rPr>
-                        <a:t>Cr. 25.96</a:t>
+                        <a:t>Cr. 27.14</a:t>
                       </a:r>
                     </a:p>
                   </a:txBody>
@@ -8191,7 +8191,7 @@
                           </a:solidFill>
                           <a:latin typeface="Times New Roman"/>
                         </a:rPr>
-                        <a:t>177  </a:t>
+                        <a:t>160  </a:t>
                       </a:r>
                     </a:p>
                   </a:txBody>
@@ -8234,7 +8234,7 @@
                           </a:solidFill>
                           <a:latin typeface="Times New Roman"/>
                         </a:rPr>
-                        <a:t>755,588</a:t>
+                        <a:t>630,975</a:t>
                       </a:r>
                       <a:br/>
                       <a:r>
@@ -8244,7 +8244,7 @@
                           </a:solidFill>
                           <a:latin typeface="Times New Roman"/>
                         </a:rPr>
-                        <a:t>Cr. 75.56</a:t>
+                        <a:t>Cr. 63.10</a:t>
                       </a:r>
                     </a:p>
                   </a:txBody>
@@ -8287,7 +8287,7 @@
                           </a:solidFill>
                           <a:latin typeface="Times New Roman"/>
                         </a:rPr>
-                        <a:t>44  </a:t>
+                        <a:t>53  </a:t>
                       </a:r>
                     </a:p>
                   </a:txBody>
@@ -8471,7 +8471,7 @@
                           </a:solidFill>
                           <a:latin typeface="Times New Roman"/>
                         </a:rPr>
-                        <a:t>514,988</a:t>
+                        <a:t>686,650</a:t>
                       </a:r>
                       <a:br/>
                       <a:r>
@@ -8481,7 +8481,7 @@
                           </a:solidFill>
                           <a:latin typeface="Times New Roman"/>
                         </a:rPr>
-                        <a:t>Cr. 51.50</a:t>
+                        <a:t>Cr. 68.67</a:t>
                       </a:r>
                     </a:p>
                   </a:txBody>
@@ -8524,7 +8524,7 @@
                           </a:solidFill>
                           <a:latin typeface="Times New Roman"/>
                         </a:rPr>
-                        <a:t>601,809</a:t>
+                        <a:t>800,112</a:t>
                       </a:r>
                       <a:br/>
                       <a:r>
@@ -8534,7 +8534,7 @@
                           </a:solidFill>
                           <a:latin typeface="Times New Roman"/>
                         </a:rPr>
-                        <a:t>Cr. 60.18</a:t>
+                        <a:t>Cr. 80.01</a:t>
                       </a:r>
                     </a:p>
                   </a:txBody>
@@ -8577,7 +8577,7 @@
                           </a:solidFill>
                           <a:latin typeface="Times New Roman"/>
                         </a:rPr>
-                        <a:t>86,822</a:t>
+                        <a:t>113,462</a:t>
                       </a:r>
                       <a:br/>
                       <a:r>
@@ -8587,7 +8587,7 @@
                           </a:solidFill>
                           <a:latin typeface="Times New Roman"/>
                         </a:rPr>
-                        <a:t>Cr. 8.68</a:t>
+                        <a:t>Cr. 11.35</a:t>
                       </a:r>
                     </a:p>
                   </a:txBody>
@@ -8673,7 +8673,7 @@
                           </a:solidFill>
                           <a:latin typeface="Times New Roman"/>
                         </a:rPr>
-                        <a:t>1,458,141</a:t>
+                        <a:t>1,259,838</a:t>
                       </a:r>
                       <a:br/>
                       <a:r>
@@ -8683,7 +8683,7 @@
                           </a:solidFill>
                           <a:latin typeface="Times New Roman"/>
                         </a:rPr>
-                        <a:t>Cr. 145.81</a:t>
+                        <a:t>Cr. 125.98</a:t>
                       </a:r>
                     </a:p>
                   </a:txBody>
@@ -8726,7 +8726,7 @@
                           </a:solidFill>
                           <a:latin typeface="Times New Roman"/>
                         </a:rPr>
-                        <a:t>29  </a:t>
+                        <a:t>39  </a:t>
                       </a:r>
                     </a:p>
                   </a:txBody>
@@ -8910,7 +8910,7 @@
                           </a:solidFill>
                           <a:latin typeface="Times New Roman"/>
                         </a:rPr>
-                        <a:t>838,142</a:t>
+                        <a:t>1,117,522</a:t>
                       </a:r>
                       <a:br/>
                       <a:r>
@@ -8920,7 +8920,7 @@
                           </a:solidFill>
                           <a:latin typeface="Times New Roman"/>
                         </a:rPr>
-                        <a:t>Cr. 83.81</a:t>
+                        <a:t>Cr. 111.75</a:t>
                       </a:r>
                     </a:p>
                   </a:txBody>
@@ -8963,7 +8963,7 @@
                           </a:solidFill>
                           <a:latin typeface="Times New Roman"/>
                         </a:rPr>
-                        <a:t>1,217,145</a:t>
+                        <a:t>1,562,963</a:t>
                       </a:r>
                       <a:br/>
                       <a:r>
@@ -8973,7 +8973,7 @@
                           </a:solidFill>
                           <a:latin typeface="Times New Roman"/>
                         </a:rPr>
-                        <a:t>Cr. 121.71</a:t>
+                        <a:t>Cr. 156.30</a:t>
                       </a:r>
                     </a:p>
                   </a:txBody>
@@ -9016,7 +9016,7 @@
                           </a:solidFill>
                           <a:latin typeface="Times New Roman"/>
                         </a:rPr>
-                        <a:t>379,004</a:t>
+                        <a:t>445,441</a:t>
                       </a:r>
                       <a:br/>
                       <a:r>
@@ -9026,7 +9026,7 @@
                           </a:solidFill>
                           <a:latin typeface="Times New Roman"/>
                         </a:rPr>
-                        <a:t>Cr. 37.90</a:t>
+                        <a:t>Cr. 44.54</a:t>
                       </a:r>
                     </a:p>
                   </a:txBody>
@@ -9069,7 +9069,7 @@
                           </a:solidFill>
                           <a:latin typeface="Times New Roman"/>
                         </a:rPr>
-                        <a:t>145  </a:t>
+                        <a:t>140  </a:t>
                       </a:r>
                     </a:p>
                   </a:txBody>
@@ -9112,7 +9112,7 @@
                           </a:solidFill>
                           <a:latin typeface="Times New Roman"/>
                         </a:rPr>
-                        <a:t>2,135,421</a:t>
+                        <a:t>1,789,603</a:t>
                       </a:r>
                       <a:br/>
                       <a:r>
@@ -9122,7 +9122,7 @@
                           </a:solidFill>
                           <a:latin typeface="Times New Roman"/>
                         </a:rPr>
-                        <a:t>Cr. 213.54</a:t>
+                        <a:t>Cr. 178.96</a:t>
                       </a:r>
                     </a:p>
                   </a:txBody>
@@ -9165,7 +9165,7 @@
                           </a:solidFill>
                           <a:latin typeface="Times New Roman"/>
                         </a:rPr>
-                        <a:t>36  </a:t>
+                        <a:t>47  </a:t>
                       </a:r>
                     </a:p>
                   </a:txBody>
@@ -9349,7 +9349,7 @@
                           </a:solidFill>
                           <a:latin typeface="Times New Roman"/>
                         </a:rPr>
-                        <a:t>1,107,192</a:t>
+                        <a:t>1,476,255</a:t>
                       </a:r>
                       <a:br/>
                       <a:r>
@@ -9359,7 +9359,7 @@
                           </a:solidFill>
                           <a:latin typeface="Times New Roman"/>
                         </a:rPr>
-                        <a:t>Cr. 110.72</a:t>
+                        <a:t>Cr. 147.63</a:t>
                       </a:r>
                     </a:p>
                   </a:txBody>
@@ -9402,7 +9402,7 @@
                           </a:solidFill>
                           <a:latin typeface="Times New Roman"/>
                         </a:rPr>
-                        <a:t>1,324,129</a:t>
+                        <a:t>1,777,301</a:t>
                       </a:r>
                       <a:br/>
                       <a:r>
@@ -9412,7 +9412,7 @@
                           </a:solidFill>
                           <a:latin typeface="Times New Roman"/>
                         </a:rPr>
-                        <a:t>Cr. 132.41</a:t>
+                        <a:t>Cr. 177.73</a:t>
                       </a:r>
                     </a:p>
                   </a:txBody>
@@ -9455,7 +9455,7 @@
                           </a:solidFill>
                           <a:latin typeface="Times New Roman"/>
                         </a:rPr>
-                        <a:t>216,938</a:t>
+                        <a:t>301,046</a:t>
                       </a:r>
                       <a:br/>
                       <a:r>
@@ -9465,7 +9465,7 @@
                           </a:solidFill>
                           <a:latin typeface="Times New Roman"/>
                         </a:rPr>
-                        <a:t>Cr. 21.69</a:t>
+                        <a:t>Cr. 30.10</a:t>
                       </a:r>
                     </a:p>
                   </a:txBody>
@@ -9551,7 +9551,7 @@
                           </a:solidFill>
                           <a:latin typeface="Times New Roman"/>
                         </a:rPr>
-                        <a:t>3,104,637</a:t>
+                        <a:t>2,651,465</a:t>
                       </a:r>
                       <a:br/>
                       <a:r>
@@ -9561,7 +9561,7 @@
                           </a:solidFill>
                           <a:latin typeface="Times New Roman"/>
                         </a:rPr>
-                        <a:t>Cr. 310.46</a:t>
+                        <a:t>Cr. 265.15</a:t>
                       </a:r>
                     </a:p>
                   </a:txBody>
@@ -9604,7 +9604,7 @@
                           </a:solidFill>
                           <a:latin typeface="Times New Roman"/>
                         </a:rPr>
-                        <a:t>30  </a:t>
+                        <a:t>40  </a:t>
                       </a:r>
                     </a:p>
                   </a:txBody>
@@ -9788,7 +9788,7 @@
                           </a:solidFill>
                           <a:latin typeface="Times New Roman"/>
                         </a:rPr>
-                        <a:t>2,901,802</a:t>
+                        <a:t>3,869,069</a:t>
                       </a:r>
                       <a:br/>
                       <a:r>
@@ -9798,7 +9798,7 @@
                           </a:solidFill>
                           <a:latin typeface="Times New Roman"/>
                         </a:rPr>
-                        <a:t>Cr. 290.18</a:t>
+                        <a:t>Cr. 386.91</a:t>
                       </a:r>
                     </a:p>
                   </a:txBody>
@@ -9841,7 +9841,7 @@
                           </a:solidFill>
                           <a:latin typeface="Times New Roman"/>
                         </a:rPr>
-                        <a:t>3,481,716</a:t>
+                        <a:t>3,545,214</a:t>
                       </a:r>
                       <a:br/>
                       <a:r>
@@ -9851,7 +9851,7 @@
                           </a:solidFill>
                           <a:latin typeface="Times New Roman"/>
                         </a:rPr>
-                        <a:t>Cr. 348.17</a:t>
+                        <a:t>Cr. 354.52</a:t>
                       </a:r>
                     </a:p>
                   </a:txBody>
@@ -9894,7 +9894,7 @@
                           </a:solidFill>
                           <a:latin typeface="Times New Roman"/>
                         </a:rPr>
-                        <a:t>579,914</a:t>
+                        <a:t>-323,855</a:t>
                       </a:r>
                       <a:br/>
                       <a:r>
@@ -9904,7 +9904,7 @@
                           </a:solidFill>
                           <a:latin typeface="Times New Roman"/>
                         </a:rPr>
-                        <a:t>Cr. 57.99</a:t>
+                        <a:t>Cr. -32.39</a:t>
                       </a:r>
                     </a:p>
                   </a:txBody>
@@ -9947,7 +9947,7 @@
                           </a:solidFill>
                           <a:latin typeface="Times New Roman"/>
                         </a:rPr>
-                        <a:t>120  </a:t>
+                        <a:t>92  </a:t>
                       </a:r>
                     </a:p>
                   </a:txBody>
@@ -9990,7 +9990,7 @@
                           </a:solidFill>
                           <a:latin typeface="Times New Roman"/>
                         </a:rPr>
-                        <a:t>8,125,490</a:t>
+                        <a:t>8,061,992</a:t>
                       </a:r>
                       <a:br/>
                       <a:r>
@@ -10000,7 +10000,7 @@
                           </a:solidFill>
                           <a:latin typeface="Times New Roman"/>
                         </a:rPr>
-                        <a:t>Cr. 812.55</a:t>
+                        <a:t>Cr. 806.20</a:t>
                       </a:r>
                     </a:p>
                   </a:txBody>
@@ -10043,7 +10043,7 @@
                           </a:solidFill>
                           <a:latin typeface="Times New Roman"/>
                         </a:rPr>
-                        <a:t>30  </a:t>
+                        <a:t>31  </a:t>
                       </a:r>
                     </a:p>
                   </a:txBody>
@@ -10227,7 +10227,7 @@
                           </a:solidFill>
                           <a:latin typeface="Times New Roman"/>
                         </a:rPr>
-                        <a:t>348,208</a:t>
+                        <a:t>464,277</a:t>
                       </a:r>
                       <a:br/>
                       <a:r>
@@ -10237,7 +10237,7 @@
                           </a:solidFill>
                           <a:latin typeface="Times New Roman"/>
                         </a:rPr>
-                        <a:t>Cr. 34.82</a:t>
+                        <a:t>Cr. 46.43</a:t>
                       </a:r>
                     </a:p>
                   </a:txBody>
@@ -10280,7 +10280,7 @@
                           </a:solidFill>
                           <a:latin typeface="Times New Roman"/>
                         </a:rPr>
-                        <a:t>670,965</a:t>
+                        <a:t>807,750</a:t>
                       </a:r>
                       <a:br/>
                       <a:r>
@@ -10290,7 +10290,7 @@
                           </a:solidFill>
                           <a:latin typeface="Times New Roman"/>
                         </a:rPr>
-                        <a:t>Cr. 67.10</a:t>
+                        <a:t>Cr. 80.78</a:t>
                       </a:r>
                     </a:p>
                   </a:txBody>
@@ -10333,7 +10333,7 @@
                           </a:solidFill>
                           <a:latin typeface="Times New Roman"/>
                         </a:rPr>
-                        <a:t>322,757</a:t>
+                        <a:t>343,473</a:t>
                       </a:r>
                       <a:br/>
                       <a:r>
@@ -10343,7 +10343,7 @@
                           </a:solidFill>
                           <a:latin typeface="Times New Roman"/>
                         </a:rPr>
-                        <a:t>Cr. 32.28</a:t>
+                        <a:t>Cr. 34.35</a:t>
                       </a:r>
                     </a:p>
                   </a:txBody>
@@ -10386,7 +10386,7 @@
                           </a:solidFill>
                           <a:latin typeface="Times New Roman"/>
                         </a:rPr>
-                        <a:t>193  </a:t>
+                        <a:t>174  </a:t>
                       </a:r>
                     </a:p>
                   </a:txBody>
@@ -10429,7 +10429,7 @@
                           </a:solidFill>
                           <a:latin typeface="Times New Roman"/>
                         </a:rPr>
-                        <a:t>721,867</a:t>
+                        <a:t>585,082</a:t>
                       </a:r>
                       <a:br/>
                       <a:r>
@@ -10439,7 +10439,7 @@
                           </a:solidFill>
                           <a:latin typeface="Times New Roman"/>
                         </a:rPr>
-                        <a:t>Cr. 72.19</a:t>
+                        <a:t>Cr. 58.51</a:t>
                       </a:r>
                     </a:p>
                   </a:txBody>
@@ -10482,7 +10482,7 @@
                           </a:solidFill>
                           <a:latin typeface="Times New Roman"/>
                         </a:rPr>
-                        <a:t>48  </a:t>
+                        <a:t>58  </a:t>
                       </a:r>
                     </a:p>
                   </a:txBody>
@@ -10666,7 +10666,7 @@
                           </a:solidFill>
                           <a:latin typeface="Times New Roman"/>
                         </a:rPr>
-                        <a:t>248,660</a:t>
+                        <a:t>331,546</a:t>
                       </a:r>
                       <a:br/>
                       <a:r>
@@ -10676,7 +10676,7 @@
                           </a:solidFill>
                           <a:latin typeface="Times New Roman"/>
                         </a:rPr>
-                        <a:t>Cr. 24.87</a:t>
+                        <a:t>Cr. 33.15</a:t>
                       </a:r>
                     </a:p>
                   </a:txBody>
@@ -10719,7 +10719,7 @@
                           </a:solidFill>
                           <a:latin typeface="Times New Roman"/>
                         </a:rPr>
-                        <a:t>260,994</a:t>
+                        <a:t>355,866</a:t>
                       </a:r>
                       <a:br/>
                       <a:r>
@@ -10729,7 +10729,7 @@
                           </a:solidFill>
                           <a:latin typeface="Times New Roman"/>
                         </a:rPr>
-                        <a:t>Cr. 26.10</a:t>
+                        <a:t>Cr. 35.59</a:t>
                       </a:r>
                     </a:p>
                   </a:txBody>
@@ -10772,7 +10772,7 @@
                           </a:solidFill>
                           <a:latin typeface="Times New Roman"/>
                         </a:rPr>
-                        <a:t>12,334</a:t>
+                        <a:t>24,320</a:t>
                       </a:r>
                       <a:br/>
                       <a:r>
@@ -10782,7 +10782,7 @@
                           </a:solidFill>
                           <a:latin typeface="Times New Roman"/>
                         </a:rPr>
-                        <a:t>Cr. 1.23</a:t>
+                        <a:t>Cr. 2.43</a:t>
                       </a:r>
                     </a:p>
                   </a:txBody>
@@ -10825,7 +10825,7 @@
                           </a:solidFill>
                           <a:latin typeface="Times New Roman"/>
                         </a:rPr>
-                        <a:t>105  </a:t>
+                        <a:t>107  </a:t>
                       </a:r>
                     </a:p>
                   </a:txBody>
@@ -10868,7 +10868,7 @@
                           </a:solidFill>
                           <a:latin typeface="Times New Roman"/>
                         </a:rPr>
-                        <a:t>733,644</a:t>
+                        <a:t>638,772</a:t>
                       </a:r>
                       <a:br/>
                       <a:r>
@@ -10878,7 +10878,7 @@
                           </a:solidFill>
                           <a:latin typeface="Times New Roman"/>
                         </a:rPr>
-                        <a:t>Cr. 73.36</a:t>
+                        <a:t>Cr. 63.88</a:t>
                       </a:r>
                     </a:p>
                   </a:txBody>
@@ -10921,7 +10921,7 @@
                           </a:solidFill>
                           <a:latin typeface="Times New Roman"/>
                         </a:rPr>
-                        <a:t>26  </a:t>
+                        <a:t>36  </a:t>
                       </a:r>
                     </a:p>
                   </a:txBody>
@@ -11105,7 +11105,7 @@
                           </a:solidFill>
                           <a:latin typeface="Times New Roman"/>
                         </a:rPr>
-                        <a:t>322,767</a:t>
+                        <a:t>430,356</a:t>
                       </a:r>
                       <a:br/>
                       <a:r>
@@ -11115,7 +11115,7 @@
                           </a:solidFill>
                           <a:latin typeface="Times New Roman"/>
                         </a:rPr>
-                        <a:t>Cr. 32.28</a:t>
+                        <a:t>Cr. 43.04</a:t>
                       </a:r>
                     </a:p>
                   </a:txBody>
@@ -11158,7 +11158,7 @@
                           </a:solidFill>
                           <a:latin typeface="Times New Roman"/>
                         </a:rPr>
-                        <a:t>318,731</a:t>
+                        <a:t>425,678</a:t>
                       </a:r>
                       <a:br/>
                       <a:r>
@@ -11168,7 +11168,7 @@
                           </a:solidFill>
                           <a:latin typeface="Times New Roman"/>
                         </a:rPr>
-                        <a:t>Cr. 31.87</a:t>
+                        <a:t>Cr. 42.57</a:t>
                       </a:r>
                     </a:p>
                   </a:txBody>
@@ -11211,7 +11211,7 @@
                           </a:solidFill>
                           <a:latin typeface="Times New Roman"/>
                         </a:rPr>
-                        <a:t>-4,036</a:t>
+                        <a:t>-4,678</a:t>
                       </a:r>
                       <a:br/>
                       <a:r>
@@ -11221,7 +11221,7 @@
                           </a:solidFill>
                           <a:latin typeface="Times New Roman"/>
                         </a:rPr>
-                        <a:t>Cr. -0.40</a:t>
+                        <a:t>Cr. -0.47</a:t>
                       </a:r>
                     </a:p>
                   </a:txBody>
@@ -11307,7 +11307,7 @@
                           </a:solidFill>
                           <a:latin typeface="Times New Roman"/>
                         </a:rPr>
-                        <a:t>972,336</a:t>
+                        <a:t>865,389</a:t>
                       </a:r>
                       <a:br/>
                       <a:r>
@@ -11317,7 +11317,7 @@
                           </a:solidFill>
                           <a:latin typeface="Times New Roman"/>
                         </a:rPr>
-                        <a:t>Cr. 97.23</a:t>
+                        <a:t>Cr. 86.54</a:t>
                       </a:r>
                     </a:p>
                   </a:txBody>
@@ -11360,7 +11360,7 @@
                           </a:solidFill>
                           <a:latin typeface="Times New Roman"/>
                         </a:rPr>
-                        <a:t>25  </a:t>
+                        <a:t>33  </a:t>
                       </a:r>
                     </a:p>
                   </a:txBody>
@@ -11544,7 +11544,7 @@
                           </a:solidFill>
                           <a:latin typeface="Times New Roman"/>
                         </a:rPr>
-                        <a:t>8,148,968</a:t>
+                        <a:t>10,865,291</a:t>
                       </a:r>
                       <a:br/>
                       <a:r>
@@ -11554,7 +11554,7 @@
                           </a:solidFill>
                           <a:latin typeface="Times New Roman"/>
                         </a:rPr>
-                        <a:t>Cr. 814.90</a:t>
+                        <a:t>Cr. 1086.53</a:t>
                       </a:r>
                     </a:p>
                   </a:txBody>
@@ -11597,7 +11597,7 @@
                           </a:solidFill>
                           <a:latin typeface="Times New Roman"/>
                         </a:rPr>
-                        <a:t>10,030,028</a:t>
+                        <a:t>12,479,934</a:t>
                       </a:r>
                       <a:br/>
                       <a:r>
@@ -11607,7 +11607,7 @@
                           </a:solidFill>
                           <a:latin typeface="Times New Roman"/>
                         </a:rPr>
-                        <a:t>Cr. 1003.00</a:t>
+                        <a:t>Cr. 1247.99</a:t>
                       </a:r>
                     </a:p>
                   </a:txBody>
@@ -11650,7 +11650,7 @@
                           </a:solidFill>
                           <a:latin typeface="Times New Roman"/>
                         </a:rPr>
-                        <a:t>1,881,060</a:t>
+                        <a:t>1,614,643</a:t>
                       </a:r>
                       <a:br/>
                       <a:r>
@@ -11660,7 +11660,7 @@
                           </a:solidFill>
                           <a:latin typeface="Times New Roman"/>
                         </a:rPr>
-                        <a:t>Cr. 188.11</a:t>
+                        <a:t>Cr. 161.46</a:t>
                       </a:r>
                     </a:p>
                   </a:txBody>
@@ -11703,7 +11703,7 @@
                           </a:solidFill>
                           <a:latin typeface="Times New Roman"/>
                         </a:rPr>
-                        <a:t>123  </a:t>
+                        <a:t>115  </a:t>
                       </a:r>
                     </a:p>
                   </a:txBody>
@@ -11746,7 +11746,7 @@
                           </a:solidFill>
                           <a:latin typeface="Times New Roman"/>
                         </a:rPr>
-                        <a:t>22,565,845</a:t>
+                        <a:t>20,115,939</a:t>
                       </a:r>
                       <a:br/>
                       <a:r>
@@ -11756,7 +11756,7 @@
                           </a:solidFill>
                           <a:latin typeface="Times New Roman"/>
                         </a:rPr>
-                        <a:t>Cr. 2256.58</a:t>
+                        <a:t>Cr. 2011.59</a:t>
                       </a:r>
                     </a:p>
                   </a:txBody>
@@ -11799,7 +11799,7 @@
                           </a:solidFill>
                           <a:latin typeface="Times New Roman"/>
                         </a:rPr>
-                        <a:t>31  </a:t>
+                        <a:t>38  </a:t>
                       </a:r>
                     </a:p>
                   </a:txBody>
@@ -11983,7 +11983,7 @@
                           </a:solidFill>
                           <a:latin typeface="Times New Roman"/>
                         </a:rPr>
-                        <a:t>-3,261</a:t>
+                        <a:t>-4,348</a:t>
                       </a:r>
                       <a:br/>
                       <a:r>
@@ -11993,7 +11993,7 @@
                           </a:solidFill>
                           <a:latin typeface="Times New Roman"/>
                         </a:rPr>
-                        <a:t>Cr. -0.33</a:t>
+                        <a:t>Cr. -0.43</a:t>
                       </a:r>
                     </a:p>
                   </a:txBody>
@@ -12036,7 +12036,7 @@
                           </a:solidFill>
                           <a:latin typeface="Times New Roman"/>
                         </a:rPr>
-                        <a:t>1,463,486</a:t>
+                        <a:t>1,569,032</a:t>
                       </a:r>
                       <a:br/>
                       <a:r>
@@ -12046,7 +12046,7 @@
                           </a:solidFill>
                           <a:latin typeface="Times New Roman"/>
                         </a:rPr>
-                        <a:t>Cr. 146.35</a:t>
+                        <a:t>Cr. 156.90</a:t>
                       </a:r>
                     </a:p>
                   </a:txBody>
@@ -12089,7 +12089,7 @@
                           </a:solidFill>
                           <a:latin typeface="Times New Roman"/>
                         </a:rPr>
-                        <a:t>1,466,747</a:t>
+                        <a:t>1,573,380</a:t>
                       </a:r>
                       <a:br/>
                       <a:r>
@@ -12099,7 +12099,7 @@
                           </a:solidFill>
                           <a:latin typeface="Times New Roman"/>
                         </a:rPr>
-                        <a:t>Cr. 146.67</a:t>
+                        <a:t>Cr. 157.34</a:t>
                       </a:r>
                     </a:p>
                   </a:txBody>
@@ -12142,7 +12142,7 @@
                           </a:solidFill>
                           <a:latin typeface="Times New Roman"/>
                         </a:rPr>
-                        <a:t>-44875  </a:t>
+                        <a:t>-36084  </a:t>
                       </a:r>
                     </a:p>
                   </a:txBody>
@@ -12185,7 +12185,7 @@
                           </a:solidFill>
                           <a:latin typeface="Times New Roman"/>
                         </a:rPr>
-                        <a:t>-1,476,531</a:t>
+                        <a:t>-1,582,077</a:t>
                       </a:r>
                       <a:br/>
                       <a:r>
@@ -12195,7 +12195,7 @@
                           </a:solidFill>
                           <a:latin typeface="Times New Roman"/>
                         </a:rPr>
-                        <a:t>Cr. -147.65</a:t>
+                        <a:t>Cr. -158.21</a:t>
                       </a:r>
                     </a:p>
                   </a:txBody>
@@ -12238,7 +12238,7 @@
                           </a:solidFill>
                           <a:latin typeface="Times New Roman"/>
                         </a:rPr>
-                        <a:t>-11219  </a:t>
+                        <a:t>-12028  </a:t>
                       </a:r>
                     </a:p>
                   </a:txBody>
@@ -12538,7 +12538,7 @@
                           </a:solidFill>
                           <a:latin typeface="Times New Roman"/>
                         </a:rPr>
-                        <a:t>BP UPTO JUN 2026</a:t>
+                        <a:t>BP UPTO JUL 2026</a:t>
                       </a:r>
                     </a:p>
                   </a:txBody>
@@ -12601,7 +12601,7 @@
                           </a:solidFill>
                           <a:latin typeface="Times New Roman"/>
                         </a:rPr>
-                        <a:t>Actuals Upto JUN 2026</a:t>
+                        <a:t>Actuals Upto JUL 2026</a:t>
                       </a:r>
                     </a:p>
                   </a:txBody>
@@ -12994,7 +12994,7 @@
                           </a:solidFill>
                           <a:latin typeface="Times New Roman"/>
                         </a:rPr>
-                        <a:t>1,676,602</a:t>
+                        <a:t>2,235,470</a:t>
                       </a:r>
                       <a:br/>
                       <a:r>
@@ -13004,7 +13004,7 @@
                           </a:solidFill>
                           <a:latin typeface="Times New Roman"/>
                         </a:rPr>
-                        <a:t>Cr. 167.66</a:t>
+                        <a:t>Cr. 223.55</a:t>
                       </a:r>
                     </a:p>
                   </a:txBody>
@@ -13047,7 +13047,7 @@
                           </a:solidFill>
                           <a:latin typeface="Times New Roman"/>
                         </a:rPr>
-                        <a:t>1,830,978</a:t>
+                        <a:t>2,454,892</a:t>
                       </a:r>
                       <a:br/>
                       <a:r>
@@ -13057,7 +13057,7 @@
                           </a:solidFill>
                           <a:latin typeface="Times New Roman"/>
                         </a:rPr>
-                        <a:t>Cr. 183.10</a:t>
+                        <a:t>Cr. 245.49</a:t>
                       </a:r>
                     </a:p>
                   </a:txBody>
@@ -13100,7 +13100,7 @@
                           </a:solidFill>
                           <a:latin typeface="Times New Roman"/>
                         </a:rPr>
-                        <a:t>154,376</a:t>
+                        <a:t>219,422</a:t>
                       </a:r>
                       <a:br/>
                       <a:r>
@@ -13110,7 +13110,7 @@
                           </a:solidFill>
                           <a:latin typeface="Times New Roman"/>
                         </a:rPr>
-                        <a:t>Cr. 15.44</a:t>
+                        <a:t>Cr. 21.94</a:t>
                       </a:r>
                     </a:p>
                   </a:txBody>
@@ -13153,7 +13153,7 @@
                           </a:solidFill>
                           <a:latin typeface="Times New Roman"/>
                         </a:rPr>
-                        <a:t>109  </a:t>
+                        <a:t>110  </a:t>
                       </a:r>
                     </a:p>
                   </a:txBody>
@@ -13196,7 +13196,7 @@
                           </a:solidFill>
                           <a:latin typeface="Times New Roman"/>
                         </a:rPr>
-                        <a:t>4,875,431</a:t>
+                        <a:t>4,251,517</a:t>
                       </a:r>
                       <a:br/>
                       <a:r>
@@ -13206,7 +13206,7 @@
                           </a:solidFill>
                           <a:latin typeface="Times New Roman"/>
                         </a:rPr>
-                        <a:t>Cr. 487.54</a:t>
+                        <a:t>Cr. 425.15</a:t>
                       </a:r>
                     </a:p>
                   </a:txBody>
@@ -13249,7 +13249,7 @@
                           </a:solidFill>
                           <a:latin typeface="Times New Roman"/>
                         </a:rPr>
-                        <a:t>27  </a:t>
+                        <a:t>37  </a:t>
                       </a:r>
                     </a:p>
                   </a:txBody>
@@ -13390,7 +13390,7 @@
                           </a:solidFill>
                           <a:latin typeface="Times New Roman"/>
                         </a:rPr>
-                        <a:t>1,025,113</a:t>
+                        <a:t>1,366,818</a:t>
                       </a:r>
                       <a:br/>
                       <a:r>
@@ -13400,7 +13400,7 @@
                           </a:solidFill>
                           <a:latin typeface="Times New Roman"/>
                         </a:rPr>
-                        <a:t>Cr. 102.51</a:t>
+                        <a:t>Cr. 136.68</a:t>
                       </a:r>
                     </a:p>
                   </a:txBody>
@@ -13443,7 +13443,7 @@
                           </a:solidFill>
                           <a:latin typeface="Times New Roman"/>
                         </a:rPr>
-                        <a:t>1,188,851</a:t>
+                        <a:t>1,579,845</a:t>
                       </a:r>
                       <a:br/>
                       <a:r>
@@ -13453,7 +13453,7 @@
                           </a:solidFill>
                           <a:latin typeface="Times New Roman"/>
                         </a:rPr>
-                        <a:t>Cr. 118.89</a:t>
+                        <a:t>Cr. 157.98</a:t>
                       </a:r>
                     </a:p>
                   </a:txBody>
@@ -13496,7 +13496,7 @@
                           </a:solidFill>
                           <a:latin typeface="Times New Roman"/>
                         </a:rPr>
-                        <a:t>163,738</a:t>
+                        <a:t>213,027</a:t>
                       </a:r>
                       <a:br/>
                       <a:r>
@@ -13506,7 +13506,7 @@
                           </a:solidFill>
                           <a:latin typeface="Times New Roman"/>
                         </a:rPr>
-                        <a:t>Cr. 16.37</a:t>
+                        <a:t>Cr. 21.30</a:t>
                       </a:r>
                     </a:p>
                   </a:txBody>
@@ -13592,7 +13592,7 @@
                           </a:solidFill>
                           <a:latin typeface="Times New Roman"/>
                         </a:rPr>
-                        <a:t>2,911,602</a:t>
+                        <a:t>2,520,608</a:t>
                       </a:r>
                       <a:br/>
                       <a:r>
@@ -13602,7 +13602,7 @@
                           </a:solidFill>
                           <a:latin typeface="Times New Roman"/>
                         </a:rPr>
-                        <a:t>Cr. 291.16</a:t>
+                        <a:t>Cr. 252.06</a:t>
                       </a:r>
                     </a:p>
                   </a:txBody>
@@ -13645,7 +13645,7 @@
                           </a:solidFill>
                           <a:latin typeface="Times New Roman"/>
                         </a:rPr>
-                        <a:t>29  </a:t>
+                        <a:t>39  </a:t>
                       </a:r>
                     </a:p>
                   </a:txBody>
@@ -13786,7 +13786,7 @@
                           </a:solidFill>
                           <a:latin typeface="Times New Roman"/>
                         </a:rPr>
-                        <a:t>71,272</a:t>
+                        <a:t>95,030</a:t>
                       </a:r>
                       <a:br/>
                       <a:r>
@@ -13796,7 +13796,7 @@
                           </a:solidFill>
                           <a:latin typeface="Times New Roman"/>
                         </a:rPr>
-                        <a:t>Cr. 7.13</a:t>
+                        <a:t>Cr. 9.50</a:t>
                       </a:r>
                     </a:p>
                   </a:txBody>
@@ -13892,7 +13892,7 @@
                           </a:solidFill>
                           <a:latin typeface="Times New Roman"/>
                         </a:rPr>
-                        <a:t>-71,191</a:t>
+                        <a:t>-94,949</a:t>
                       </a:r>
                       <a:br/>
                       <a:r>
@@ -13902,7 +13902,7 @@
                           </a:solidFill>
                           <a:latin typeface="Times New Roman"/>
                         </a:rPr>
-                        <a:t>Cr. -7.12</a:t>
+                        <a:t>Cr. -9.49</a:t>
                       </a:r>
                     </a:p>
                   </a:txBody>
@@ -14182,7 +14182,7 @@
                           </a:solidFill>
                           <a:latin typeface="Times New Roman"/>
                         </a:rPr>
-                        <a:t>194,050</a:t>
+                        <a:t>258,733</a:t>
                       </a:r>
                       <a:br/>
                       <a:r>
@@ -14192,7 +14192,7 @@
                           </a:solidFill>
                           <a:latin typeface="Times New Roman"/>
                         </a:rPr>
-                        <a:t>Cr. 19.40</a:t>
+                        <a:t>Cr. 25.87</a:t>
                       </a:r>
                     </a:p>
                   </a:txBody>
@@ -14235,7 +14235,7 @@
                           </a:solidFill>
                           <a:latin typeface="Times New Roman"/>
                         </a:rPr>
-                        <a:t>201,303</a:t>
+                        <a:t>269,991</a:t>
                       </a:r>
                       <a:br/>
                       <a:r>
@@ -14245,7 +14245,7 @@
                           </a:solidFill>
                           <a:latin typeface="Times New Roman"/>
                         </a:rPr>
-                        <a:t>Cr. 20.13</a:t>
+                        <a:t>Cr. 27.00</a:t>
                       </a:r>
                     </a:p>
                   </a:txBody>
@@ -14288,7 +14288,7 @@
                           </a:solidFill>
                           <a:latin typeface="Times New Roman"/>
                         </a:rPr>
-                        <a:t>7,254</a:t>
+                        <a:t>11,258</a:t>
                       </a:r>
                       <a:br/>
                       <a:r>
@@ -14298,7 +14298,7 @@
                           </a:solidFill>
                           <a:latin typeface="Times New Roman"/>
                         </a:rPr>
-                        <a:t>Cr. 0.73</a:t>
+                        <a:t>Cr. 1.13</a:t>
                       </a:r>
                     </a:p>
                   </a:txBody>
@@ -14384,7 +14384,7 @@
                           </a:solidFill>
                           <a:latin typeface="Times New Roman"/>
                         </a:rPr>
-                        <a:t>574,895</a:t>
+                        <a:t>506,207</a:t>
                       </a:r>
                       <a:br/>
                       <a:r>
@@ -14394,7 +14394,7 @@
                           </a:solidFill>
                           <a:latin typeface="Times New Roman"/>
                         </a:rPr>
-                        <a:t>Cr. 57.49</a:t>
+                        <a:t>Cr. 50.62</a:t>
                       </a:r>
                     </a:p>
                   </a:txBody>
@@ -14437,7 +14437,7 @@
                           </a:solidFill>
                           <a:latin typeface="Times New Roman"/>
                         </a:rPr>
-                        <a:t>26  </a:t>
+                        <a:t>35  </a:t>
                       </a:r>
                     </a:p>
                   </a:txBody>
@@ -14578,7 +14578,7 @@
                           </a:solidFill>
                           <a:latin typeface="Times New Roman"/>
                         </a:rPr>
-                        <a:t>124,152</a:t>
+                        <a:t>165,536</a:t>
                       </a:r>
                       <a:br/>
                       <a:r>
@@ -14588,7 +14588,7 @@
                           </a:solidFill>
                           <a:latin typeface="Times New Roman"/>
                         </a:rPr>
-                        <a:t>Cr. 12.42</a:t>
+                        <a:t>Cr. 16.55</a:t>
                       </a:r>
                     </a:p>
                   </a:txBody>
@@ -14631,7 +14631,7 @@
                           </a:solidFill>
                           <a:latin typeface="Times New Roman"/>
                         </a:rPr>
-                        <a:t>130,168</a:t>
+                        <a:t>173,507</a:t>
                       </a:r>
                       <a:br/>
                       <a:r>
@@ -14641,7 +14641,7 @@
                           </a:solidFill>
                           <a:latin typeface="Times New Roman"/>
                         </a:rPr>
-                        <a:t>Cr. 13.02</a:t>
+                        <a:t>Cr. 17.35</a:t>
                       </a:r>
                     </a:p>
                   </a:txBody>
@@ -14684,7 +14684,7 @@
                           </a:solidFill>
                           <a:latin typeface="Times New Roman"/>
                         </a:rPr>
-                        <a:t>6,016</a:t>
+                        <a:t>7,971</a:t>
                       </a:r>
                       <a:br/>
                       <a:r>
@@ -14694,7 +14694,7 @@
                           </a:solidFill>
                           <a:latin typeface="Times New Roman"/>
                         </a:rPr>
-                        <a:t>Cr. 0.60</a:t>
+                        <a:t>Cr. 0.80</a:t>
                       </a:r>
                     </a:p>
                   </a:txBody>
@@ -14780,7 +14780,7 @@
                           </a:solidFill>
                           <a:latin typeface="Times New Roman"/>
                         </a:rPr>
-                        <a:t>366,441</a:t>
+                        <a:t>323,102</a:t>
                       </a:r>
                       <a:br/>
                       <a:r>
@@ -14790,7 +14790,7 @@
                           </a:solidFill>
                           <a:latin typeface="Times New Roman"/>
                         </a:rPr>
-                        <a:t>Cr. 36.64</a:t>
+                        <a:t>Cr. 32.31</a:t>
                       </a:r>
                     </a:p>
                   </a:txBody>
@@ -14833,7 +14833,7 @@
                           </a:solidFill>
                           <a:latin typeface="Times New Roman"/>
                         </a:rPr>
-                        <a:t>26  </a:t>
+                        <a:t>35  </a:t>
                       </a:r>
                     </a:p>
                   </a:txBody>
@@ -14974,7 +14974,7 @@
                           </a:solidFill>
                           <a:latin typeface="Times New Roman"/>
                         </a:rPr>
-                        <a:t>170,049</a:t>
+                        <a:t>226,732</a:t>
                       </a:r>
                       <a:br/>
                       <a:r>
@@ -14984,7 +14984,7 @@
                           </a:solidFill>
                           <a:latin typeface="Times New Roman"/>
                         </a:rPr>
-                        <a:t>Cr. 17.00</a:t>
+                        <a:t>Cr. 22.67</a:t>
                       </a:r>
                     </a:p>
                   </a:txBody>
@@ -15027,7 +15027,7 @@
                           </a:solidFill>
                           <a:latin typeface="Times New Roman"/>
                         </a:rPr>
-                        <a:t>218,804</a:t>
+                        <a:t>290,482</a:t>
                       </a:r>
                       <a:br/>
                       <a:r>
@@ -15037,7 +15037,7 @@
                           </a:solidFill>
                           <a:latin typeface="Times New Roman"/>
                         </a:rPr>
-                        <a:t>Cr. 21.88</a:t>
+                        <a:t>Cr. 29.05</a:t>
                       </a:r>
                     </a:p>
                   </a:txBody>
@@ -15080,7 +15080,7 @@
                           </a:solidFill>
                           <a:latin typeface="Times New Roman"/>
                         </a:rPr>
-                        <a:t>48,755</a:t>
+                        <a:t>63,750</a:t>
                       </a:r>
                       <a:br/>
                       <a:r>
@@ -15090,7 +15090,7 @@
                           </a:solidFill>
                           <a:latin typeface="Times New Roman"/>
                         </a:rPr>
-                        <a:t>Cr. 4.88</a:t>
+                        <a:t>Cr. 6.37</a:t>
                       </a:r>
                     </a:p>
                   </a:txBody>
@@ -15133,7 +15133,7 @@
                           </a:solidFill>
                           <a:latin typeface="Times New Roman"/>
                         </a:rPr>
-                        <a:t>129  </a:t>
+                        <a:t>128  </a:t>
                       </a:r>
                     </a:p>
                   </a:txBody>
@@ -15176,7 +15176,7 @@
                           </a:solidFill>
                           <a:latin typeface="Times New Roman"/>
                         </a:rPr>
-                        <a:t>461,393</a:t>
+                        <a:t>389,715</a:t>
                       </a:r>
                       <a:br/>
                       <a:r>
@@ -15186,7 +15186,7 @@
                           </a:solidFill>
                           <a:latin typeface="Times New Roman"/>
                         </a:rPr>
-                        <a:t>Cr. 46.14</a:t>
+                        <a:t>Cr. 38.97</a:t>
                       </a:r>
                     </a:p>
                   </a:txBody>
@@ -15229,7 +15229,7 @@
                           </a:solidFill>
                           <a:latin typeface="Times New Roman"/>
                         </a:rPr>
-                        <a:t>32  </a:t>
+                        <a:t>43  </a:t>
                       </a:r>
                     </a:p>
                   </a:txBody>
@@ -15370,7 +15370,7 @@
                           </a:solidFill>
                           <a:latin typeface="Times New Roman"/>
                         </a:rPr>
-                        <a:t>19,325</a:t>
+                        <a:t>25,767</a:t>
                       </a:r>
                       <a:br/>
                       <a:r>
@@ -15380,7 +15380,7 @@
                           </a:solidFill>
                           <a:latin typeface="Times New Roman"/>
                         </a:rPr>
-                        <a:t>Cr. 1.93</a:t>
+                        <a:t>Cr. 2.58</a:t>
                       </a:r>
                     </a:p>
                   </a:txBody>
@@ -15423,7 +15423,7 @@
                           </a:solidFill>
                           <a:latin typeface="Times New Roman"/>
                         </a:rPr>
-                        <a:t>43,958</a:t>
+                        <a:t>54,545</a:t>
                       </a:r>
                       <a:br/>
                       <a:r>
@@ -15433,7 +15433,7 @@
                           </a:solidFill>
                           <a:latin typeface="Times New Roman"/>
                         </a:rPr>
-                        <a:t>Cr. 4.40</a:t>
+                        <a:t>Cr. 5.45</a:t>
                       </a:r>
                     </a:p>
                   </a:txBody>
@@ -15476,7 +15476,7 @@
                           </a:solidFill>
                           <a:latin typeface="Times New Roman"/>
                         </a:rPr>
-                        <a:t>24,633</a:t>
+                        <a:t>28,778</a:t>
                       </a:r>
                       <a:br/>
                       <a:r>
@@ -15486,7 +15486,7 @@
                           </a:solidFill>
                           <a:latin typeface="Times New Roman"/>
                         </a:rPr>
-                        <a:t>Cr. 2.46</a:t>
+                        <a:t>Cr. 2.88</a:t>
                       </a:r>
                     </a:p>
                   </a:txBody>
@@ -15529,7 +15529,7 @@
                           </a:solidFill>
                           <a:latin typeface="Times New Roman"/>
                         </a:rPr>
-                        <a:t>227  </a:t>
+                        <a:t>212  </a:t>
                       </a:r>
                     </a:p>
                   </a:txBody>
@@ -15572,7 +15572,7 @@
                           </a:solidFill>
                           <a:latin typeface="Times New Roman"/>
                         </a:rPr>
-                        <a:t>33,342</a:t>
+                        <a:t>22,755</a:t>
                       </a:r>
                       <a:br/>
                       <a:r>
@@ -15582,7 +15582,7 @@
                           </a:solidFill>
                           <a:latin typeface="Times New Roman"/>
                         </a:rPr>
-                        <a:t>Cr. 3.33</a:t>
+                        <a:t>Cr. 2.28</a:t>
                       </a:r>
                     </a:p>
                   </a:txBody>
@@ -15625,7 +15625,7 @@
                           </a:solidFill>
                           <a:latin typeface="Times New Roman"/>
                         </a:rPr>
-                        <a:t>57  </a:t>
+                        <a:t>71  </a:t>
                       </a:r>
                     </a:p>
                   </a:txBody>
@@ -15766,7 +15766,7 @@
                           </a:solidFill>
                           <a:latin typeface="Times New Roman"/>
                         </a:rPr>
-                        <a:t>52,478</a:t>
+                        <a:t>69,971</a:t>
                       </a:r>
                       <a:br/>
                       <a:r>
@@ -15776,7 +15776,7 @@
                           </a:solidFill>
                           <a:latin typeface="Times New Roman"/>
                         </a:rPr>
-                        <a:t>Cr. 5.25</a:t>
+                        <a:t>Cr. 7.00</a:t>
                       </a:r>
                     </a:p>
                   </a:txBody>
@@ -15819,7 +15819,7 @@
                           </a:solidFill>
                           <a:latin typeface="Times New Roman"/>
                         </a:rPr>
-                        <a:t>73,688</a:t>
+                        <a:t>98,022</a:t>
                       </a:r>
                       <a:br/>
                       <a:r>
@@ -15829,7 +15829,7 @@
                           </a:solidFill>
                           <a:latin typeface="Times New Roman"/>
                         </a:rPr>
-                        <a:t>Cr. 7.37</a:t>
+                        <a:t>Cr. 9.80</a:t>
                       </a:r>
                     </a:p>
                   </a:txBody>
@@ -15872,7 +15872,7 @@
                           </a:solidFill>
                           <a:latin typeface="Times New Roman"/>
                         </a:rPr>
-                        <a:t>21,210</a:t>
+                        <a:t>28,051</a:t>
                       </a:r>
                       <a:br/>
                       <a:r>
@@ -15882,7 +15882,7 @@
                           </a:solidFill>
                           <a:latin typeface="Times New Roman"/>
                         </a:rPr>
-                        <a:t>Cr. 2.12</a:t>
+                        <a:t>Cr. 2.81</a:t>
                       </a:r>
                     </a:p>
                   </a:txBody>
@@ -15968,7 +15968,7 @@
                           </a:solidFill>
                           <a:latin typeface="Times New Roman"/>
                         </a:rPr>
-                        <a:t>136,225</a:t>
+                        <a:t>111,891</a:t>
                       </a:r>
                       <a:br/>
                       <a:r>
@@ -15978,7 +15978,7 @@
                           </a:solidFill>
                           <a:latin typeface="Times New Roman"/>
                         </a:rPr>
-                        <a:t>Cr. 13.62</a:t>
+                        <a:t>Cr. 11.19</a:t>
                       </a:r>
                     </a:p>
                   </a:txBody>
@@ -16021,7 +16021,7 @@
                           </a:solidFill>
                           <a:latin typeface="Times New Roman"/>
                         </a:rPr>
-                        <a:t>35  </a:t>
+                        <a:t>47  </a:t>
                       </a:r>
                     </a:p>
                   </a:txBody>
@@ -16162,7 +16162,7 @@
                           </a:solidFill>
                           <a:latin typeface="Times New Roman"/>
                         </a:rPr>
-                        <a:t>131,958</a:t>
+                        <a:t>175,944</a:t>
                       </a:r>
                       <a:br/>
                       <a:r>
@@ -16172,7 +16172,7 @@
                           </a:solidFill>
                           <a:latin typeface="Times New Roman"/>
                         </a:rPr>
-                        <a:t>Cr. 13.20</a:t>
+                        <a:t>Cr. 17.59</a:t>
                       </a:r>
                     </a:p>
                   </a:txBody>
@@ -16215,7 +16215,7 @@
                           </a:solidFill>
                           <a:latin typeface="Times New Roman"/>
                         </a:rPr>
-                        <a:t>115,964</a:t>
+                        <a:t>250,793</a:t>
                       </a:r>
                       <a:br/>
                       <a:r>
@@ -16225,7 +16225,7 @@
                           </a:solidFill>
                           <a:latin typeface="Times New Roman"/>
                         </a:rPr>
-                        <a:t>Cr. 11.60</a:t>
+                        <a:t>Cr. 25.08</a:t>
                       </a:r>
                     </a:p>
                   </a:txBody>
@@ -16268,7 +16268,7 @@
                           </a:solidFill>
                           <a:latin typeface="Times New Roman"/>
                         </a:rPr>
-                        <a:t>-15,994</a:t>
+                        <a:t>74,849</a:t>
                       </a:r>
                       <a:br/>
                       <a:r>
@@ -16278,7 +16278,7 @@
                           </a:solidFill>
                           <a:latin typeface="Times New Roman"/>
                         </a:rPr>
-                        <a:t>Cr. -1.60</a:t>
+                        <a:t>Cr. 7.48</a:t>
                       </a:r>
                     </a:p>
                   </a:txBody>
@@ -16321,7 +16321,7 @@
                           </a:solidFill>
                           <a:latin typeface="Times New Roman"/>
                         </a:rPr>
-                        <a:t>88  </a:t>
+                        <a:t>143  </a:t>
                       </a:r>
                     </a:p>
                   </a:txBody>
@@ -16364,7 +16364,7 @@
                           </a:solidFill>
                           <a:latin typeface="Times New Roman"/>
                         </a:rPr>
-                        <a:t>411,868</a:t>
+                        <a:t>277,039</a:t>
                       </a:r>
                       <a:br/>
                       <a:r>
@@ -16374,7 +16374,7 @@
                           </a:solidFill>
                           <a:latin typeface="Times New Roman"/>
                         </a:rPr>
-                        <a:t>Cr. 41.19</a:t>
+                        <a:t>Cr. 27.70</a:t>
                       </a:r>
                     </a:p>
                   </a:txBody>
@@ -16417,7 +16417,7 @@
                           </a:solidFill>
                           <a:latin typeface="Times New Roman"/>
                         </a:rPr>
-                        <a:t>22  </a:t>
+                        <a:t>48  </a:t>
                       </a:r>
                     </a:p>
                   </a:txBody>
@@ -16558,7 +16558,7 @@
                           </a:solidFill>
                           <a:latin typeface="Times New Roman"/>
                         </a:rPr>
-                        <a:t>4,012</a:t>
+                        <a:t>5,349</a:t>
                       </a:r>
                       <a:br/>
                       <a:r>
@@ -16568,7 +16568,7 @@
                           </a:solidFill>
                           <a:latin typeface="Times New Roman"/>
                         </a:rPr>
-                        <a:t>Cr. 0.40</a:t>
+                        <a:t>Cr. 0.53</a:t>
                       </a:r>
                     </a:p>
                   </a:txBody>
@@ -16611,7 +16611,7 @@
                           </a:solidFill>
                           <a:latin typeface="Times New Roman"/>
                         </a:rPr>
-                        <a:t>5,394</a:t>
+                        <a:t>9,177</a:t>
                       </a:r>
                       <a:br/>
                       <a:r>
@@ -16621,7 +16621,7 @@
                           </a:solidFill>
                           <a:latin typeface="Times New Roman"/>
                         </a:rPr>
-                        <a:t>Cr. 0.54</a:t>
+                        <a:t>Cr. 0.92</a:t>
                       </a:r>
                     </a:p>
                   </a:txBody>
@@ -16664,7 +16664,7 @@
                           </a:solidFill>
                           <a:latin typeface="Times New Roman"/>
                         </a:rPr>
-                        <a:t>1,382</a:t>
+                        <a:t>3,828</a:t>
                       </a:r>
                       <a:br/>
                       <a:r>
@@ -16674,7 +16674,7 @@
                           </a:solidFill>
                           <a:latin typeface="Times New Roman"/>
                         </a:rPr>
-                        <a:t>Cr. 0.14</a:t>
+                        <a:t>Cr. 0.38</a:t>
                       </a:r>
                     </a:p>
                   </a:txBody>
@@ -16717,7 +16717,7 @@
                           </a:solidFill>
                           <a:latin typeface="Times New Roman"/>
                         </a:rPr>
-                        <a:t>134  </a:t>
+                        <a:t>172  </a:t>
                       </a:r>
                     </a:p>
                   </a:txBody>
@@ -16760,7 +16760,7 @@
                           </a:solidFill>
                           <a:latin typeface="Times New Roman"/>
                         </a:rPr>
-                        <a:t>10,654</a:t>
+                        <a:t>6,871</a:t>
                       </a:r>
                       <a:br/>
                       <a:r>
@@ -16770,7 +16770,7 @@
                           </a:solidFill>
                           <a:latin typeface="Times New Roman"/>
                         </a:rPr>
-                        <a:t>Cr. 1.07</a:t>
+                        <a:t>Cr. 0.69</a:t>
                       </a:r>
                     </a:p>
                   </a:txBody>
@@ -16813,7 +16813,7 @@
                           </a:solidFill>
                           <a:latin typeface="Times New Roman"/>
                         </a:rPr>
-                        <a:t>34  </a:t>
+                        <a:t>57  </a:t>
                       </a:r>
                     </a:p>
                   </a:txBody>
@@ -16954,7 +16954,7 @@
                           </a:solidFill>
                           <a:latin typeface="Times New Roman"/>
                         </a:rPr>
-                        <a:t>77,020</a:t>
+                        <a:t>102,694</a:t>
                       </a:r>
                       <a:br/>
                       <a:r>
@@ -16964,7 +16964,7 @@
                           </a:solidFill>
                           <a:latin typeface="Times New Roman"/>
                         </a:rPr>
-                        <a:t>Cr. 7.70</a:t>
+                        <a:t>Cr. 10.27</a:t>
                       </a:r>
                     </a:p>
                   </a:txBody>
@@ -17007,7 +17007,7 @@
                           </a:solidFill>
                           <a:latin typeface="Times New Roman"/>
                         </a:rPr>
-                        <a:t>130,831</a:t>
+                        <a:t>176,120</a:t>
                       </a:r>
                       <a:br/>
                       <a:r>
@@ -17017,7 +17017,7 @@
                           </a:solidFill>
                           <a:latin typeface="Times New Roman"/>
                         </a:rPr>
-                        <a:t>Cr. 13.08</a:t>
+                        <a:t>Cr. 17.61</a:t>
                       </a:r>
                     </a:p>
                   </a:txBody>
@@ -17060,7 +17060,7 @@
                           </a:solidFill>
                           <a:latin typeface="Times New Roman"/>
                         </a:rPr>
-                        <a:t>53,811</a:t>
+                        <a:t>73,426</a:t>
                       </a:r>
                       <a:br/>
                       <a:r>
@@ -17070,7 +17070,7 @@
                           </a:solidFill>
                           <a:latin typeface="Times New Roman"/>
                         </a:rPr>
-                        <a:t>Cr. 5.38</a:t>
+                        <a:t>Cr. 7.34</a:t>
                       </a:r>
                     </a:p>
                   </a:txBody>
@@ -17113,7 +17113,7 @@
                           </a:solidFill>
                           <a:latin typeface="Times New Roman"/>
                         </a:rPr>
-                        <a:t>170  </a:t>
+                        <a:t>172  </a:t>
                       </a:r>
                     </a:p>
                   </a:txBody>
@@ -17156,7 +17156,7 @@
                           </a:solidFill>
                           <a:latin typeface="Times New Roman"/>
                         </a:rPr>
-                        <a:t>177,250</a:t>
+                        <a:t>131,961</a:t>
                       </a:r>
                       <a:br/>
                       <a:r>
@@ -17166,7 +17166,7 @@
                           </a:solidFill>
                           <a:latin typeface="Times New Roman"/>
                         </a:rPr>
-                        <a:t>Cr. 17.73</a:t>
+                        <a:t>Cr. 13.20</a:t>
                       </a:r>
                     </a:p>
                   </a:txBody>
@@ -17209,7 +17209,7 @@
                           </a:solidFill>
                           <a:latin typeface="Times New Roman"/>
                         </a:rPr>
-                        <a:t>42  </a:t>
+                        <a:t>57  </a:t>
                       </a:r>
                     </a:p>
                   </a:txBody>
@@ -17350,7 +17350,7 @@
                           </a:solidFill>
                           <a:latin typeface="Times New Roman"/>
                         </a:rPr>
-                        <a:t>94,854</a:t>
+                        <a:t>126,473</a:t>
                       </a:r>
                       <a:br/>
                       <a:r>
@@ -17360,7 +17360,7 @@
                           </a:solidFill>
                           <a:latin typeface="Times New Roman"/>
                         </a:rPr>
-                        <a:t>Cr. 9.49</a:t>
+                        <a:t>Cr. 12.65</a:t>
                       </a:r>
                     </a:p>
                   </a:txBody>
@@ -17403,7 +17403,7 @@
                           </a:solidFill>
                           <a:latin typeface="Times New Roman"/>
                         </a:rPr>
-                        <a:t>318,899</a:t>
+                        <a:t>358,455</a:t>
                       </a:r>
                       <a:br/>
                       <a:r>
@@ -17413,7 +17413,7 @@
                           </a:solidFill>
                           <a:latin typeface="Times New Roman"/>
                         </a:rPr>
-                        <a:t>Cr. 31.89</a:t>
+                        <a:t>Cr. 35.85</a:t>
                       </a:r>
                     </a:p>
                   </a:txBody>
@@ -17456,7 +17456,7 @@
                           </a:solidFill>
                           <a:latin typeface="Times New Roman"/>
                         </a:rPr>
-                        <a:t>224,044</a:t>
+                        <a:t>231,982</a:t>
                       </a:r>
                       <a:br/>
                       <a:r>
@@ -17466,7 +17466,7 @@
                           </a:solidFill>
                           <a:latin typeface="Times New Roman"/>
                         </a:rPr>
-                        <a:t>Cr. 22.40</a:t>
+                        <a:t>Cr. 23.20</a:t>
                       </a:r>
                     </a:p>
                   </a:txBody>
@@ -17509,7 +17509,7 @@
                           </a:solidFill>
                           <a:latin typeface="Times New Roman"/>
                         </a:rPr>
-                        <a:t>336  </a:t>
+                        <a:t>283  </a:t>
                       </a:r>
                     </a:p>
                   </a:txBody>
@@ -17552,7 +17552,7 @@
                           </a:solidFill>
                           <a:latin typeface="Times New Roman"/>
                         </a:rPr>
-                        <a:t>60,519</a:t>
+                        <a:t>20,963</a:t>
                       </a:r>
                       <a:br/>
                       <a:r>
@@ -17562,7 +17562,7 @@
                           </a:solidFill>
                           <a:latin typeface="Times New Roman"/>
                         </a:rPr>
-                        <a:t>Cr. 6.05</a:t>
+                        <a:t>Cr. 2.10</a:t>
                       </a:r>
                     </a:p>
                   </a:txBody>
@@ -17605,7 +17605,7 @@
                           </a:solidFill>
                           <a:latin typeface="Times New Roman"/>
                         </a:rPr>
-                        <a:t>84  </a:t>
+                        <a:t>94  </a:t>
                       </a:r>
                     </a:p>
                   </a:txBody>
@@ -17746,7 +17746,7 @@
                           </a:solidFill>
                           <a:latin typeface="Times New Roman"/>
                         </a:rPr>
-                        <a:t>3,640,887</a:t>
+                        <a:t>4,854,516</a:t>
                       </a:r>
                       <a:br/>
                       <a:r>
@@ -17756,7 +17756,7 @@
                           </a:solidFill>
                           <a:latin typeface="Times New Roman"/>
                         </a:rPr>
-                        <a:t>Cr. 364.09</a:t>
+                        <a:t>Cr. 485.45</a:t>
                       </a:r>
                     </a:p>
                   </a:txBody>
@@ -17799,7 +17799,7 @@
                           </a:solidFill>
                           <a:latin typeface="Times New Roman"/>
                         </a:rPr>
-                        <a:t>4,258,919</a:t>
+                        <a:t>5,715,910</a:t>
                       </a:r>
                       <a:br/>
                       <a:r>
@@ -17809,7 +17809,7 @@
                           </a:solidFill>
                           <a:latin typeface="Times New Roman"/>
                         </a:rPr>
-                        <a:t>Cr. 425.89</a:t>
+                        <a:t>Cr. 571.59</a:t>
                       </a:r>
                     </a:p>
                   </a:txBody>
@@ -17852,7 +17852,7 @@
                           </a:solidFill>
                           <a:latin typeface="Times New Roman"/>
                         </a:rPr>
-                        <a:t>618,032</a:t>
+                        <a:t>861,394</a:t>
                       </a:r>
                       <a:br/>
                       <a:r>
@@ -17862,7 +17862,7 @@
                           </a:solidFill>
                           <a:latin typeface="Times New Roman"/>
                         </a:rPr>
-                        <a:t>Cr. 61.80</a:t>
+                        <a:t>Cr. 86.14</a:t>
                       </a:r>
                     </a:p>
                   </a:txBody>
@@ -17905,7 +17905,7 @@
                           </a:solidFill>
                           <a:latin typeface="Times New Roman"/>
                         </a:rPr>
-                        <a:t>117  </a:t>
+                        <a:t>118  </a:t>
                       </a:r>
                     </a:p>
                   </a:txBody>
@@ -17948,7 +17948,7 @@
                           </a:solidFill>
                           <a:latin typeface="Times New Roman"/>
                         </a:rPr>
-                        <a:t>10,304,628</a:t>
+                        <a:t>8,847,637</a:t>
                       </a:r>
                       <a:br/>
                       <a:r>
@@ -17958,7 +17958,7 @@
                           </a:solidFill>
                           <a:latin typeface="Times New Roman"/>
                         </a:rPr>
-                        <a:t>Cr. 1030.46</a:t>
+                        <a:t>Cr. 884.76</a:t>
                       </a:r>
                     </a:p>
                   </a:txBody>
@@ -18001,7 +18001,7 @@
                           </a:solidFill>
                           <a:latin typeface="Times New Roman"/>
                         </a:rPr>
-                        <a:t>29  </a:t>
+                        <a:t>39  </a:t>
                       </a:r>
                     </a:p>
                   </a:txBody>
@@ -18301,7 +18301,7 @@
                           </a:solidFill>
                           <a:latin typeface="Times New Roman"/>
                         </a:rPr>
-                        <a:t>BP UPTO JUN 2026</a:t>
+                        <a:t>BP UPTO JUL 2026</a:t>
                       </a:r>
                     </a:p>
                   </a:txBody>
@@ -18364,7 +18364,7 @@
                           </a:solidFill>
                           <a:latin typeface="Times New Roman"/>
                         </a:rPr>
-                        <a:t>Actuals Upto JUN 2026</a:t>
+                        <a:t>Actuals Upto JUL 2026</a:t>
                       </a:r>
                     </a:p>
                   </a:txBody>
@@ -18757,7 +18757,7 @@
                           </a:solidFill>
                           <a:latin typeface="Times New Roman"/>
                         </a:rPr>
-                        <a:t>267,188</a:t>
+                        <a:t>356,251</a:t>
                       </a:r>
                       <a:br/>
                       <a:r>
@@ -18767,7 +18767,7 @@
                           </a:solidFill>
                           <a:latin typeface="Times New Roman"/>
                         </a:rPr>
-                        <a:t>Cr. 26.72</a:t>
+                        <a:t>Cr. 35.63</a:t>
                       </a:r>
                     </a:p>
                   </a:txBody>
@@ -18810,7 +18810,7 @@
                           </a:solidFill>
                           <a:latin typeface="Times New Roman"/>
                         </a:rPr>
-                        <a:t>588,298</a:t>
+                        <a:t>588,317</a:t>
                       </a:r>
                       <a:br/>
                       <a:r>
@@ -18863,7 +18863,7 @@
                           </a:solidFill>
                           <a:latin typeface="Times New Roman"/>
                         </a:rPr>
-                        <a:t>321,110</a:t>
+                        <a:t>232,066</a:t>
                       </a:r>
                       <a:br/>
                       <a:r>
@@ -18873,7 +18873,7 @@
                           </a:solidFill>
                           <a:latin typeface="Times New Roman"/>
                         </a:rPr>
-                        <a:t>Cr. 32.11</a:t>
+                        <a:t>Cr. 23.21</a:t>
                       </a:r>
                     </a:p>
                   </a:txBody>
@@ -18916,7 +18916,7 @@
                           </a:solidFill>
                           <a:latin typeface="Times New Roman"/>
                         </a:rPr>
-                        <a:t>220  </a:t>
+                        <a:t>165  </a:t>
                       </a:r>
                     </a:p>
                   </a:txBody>
@@ -18959,7 +18959,7 @@
                           </a:solidFill>
                           <a:latin typeface="Times New Roman"/>
                         </a:rPr>
-                        <a:t>480,454</a:t>
+                        <a:t>480,435</a:t>
                       </a:r>
                       <a:br/>
                       <a:r>
@@ -18969,7 +18969,7 @@
                           </a:solidFill>
                           <a:latin typeface="Times New Roman"/>
                         </a:rPr>
-                        <a:t>Cr. 48.05</a:t>
+                        <a:t>Cr. 48.04</a:t>
                       </a:r>
                     </a:p>
                   </a:txBody>
@@ -19153,7 +19153,7 @@
                           </a:solidFill>
                           <a:latin typeface="Times New Roman"/>
                         </a:rPr>
-                        <a:t>37,487</a:t>
+                        <a:t>49,982</a:t>
                       </a:r>
                       <a:br/>
                       <a:r>
@@ -19163,7 +19163,7 @@
                           </a:solidFill>
                           <a:latin typeface="Times New Roman"/>
                         </a:rPr>
-                        <a:t>Cr. 3.75</a:t>
+                        <a:t>Cr. 5.00</a:t>
                       </a:r>
                     </a:p>
                   </a:txBody>
@@ -19206,7 +19206,7 @@
                           </a:solidFill>
                           <a:latin typeface="Times New Roman"/>
                         </a:rPr>
-                        <a:t>42,862</a:t>
+                        <a:t>63,019</a:t>
                       </a:r>
                       <a:br/>
                       <a:r>
@@ -19216,7 +19216,7 @@
                           </a:solidFill>
                           <a:latin typeface="Times New Roman"/>
                         </a:rPr>
-                        <a:t>Cr. 4.29</a:t>
+                        <a:t>Cr. 6.30</a:t>
                       </a:r>
                     </a:p>
                   </a:txBody>
@@ -19259,7 +19259,7 @@
                           </a:solidFill>
                           <a:latin typeface="Times New Roman"/>
                         </a:rPr>
-                        <a:t>5,375</a:t>
+                        <a:t>13,037</a:t>
                       </a:r>
                       <a:br/>
                       <a:r>
@@ -19269,7 +19269,7 @@
                           </a:solidFill>
                           <a:latin typeface="Times New Roman"/>
                         </a:rPr>
-                        <a:t>Cr. 0.54</a:t>
+                        <a:t>Cr. 1.30</a:t>
                       </a:r>
                     </a:p>
                   </a:txBody>
@@ -19312,7 +19312,7 @@
                           </a:solidFill>
                           <a:latin typeface="Times New Roman"/>
                         </a:rPr>
-                        <a:t>114  </a:t>
+                        <a:t>126  </a:t>
                       </a:r>
                     </a:p>
                   </a:txBody>
@@ -19355,7 +19355,7 @@
                           </a:solidFill>
                           <a:latin typeface="Times New Roman"/>
                         </a:rPr>
-                        <a:t>107,085</a:t>
+                        <a:t>86,928</a:t>
                       </a:r>
                       <a:br/>
                       <a:r>
@@ -19365,7 +19365,7 @@
                           </a:solidFill>
                           <a:latin typeface="Times New Roman"/>
                         </a:rPr>
-                        <a:t>Cr. 10.71</a:t>
+                        <a:t>Cr. 8.69</a:t>
                       </a:r>
                     </a:p>
                   </a:txBody>
@@ -19408,7 +19408,7 @@
                           </a:solidFill>
                           <a:latin typeface="Times New Roman"/>
                         </a:rPr>
-                        <a:t>29  </a:t>
+                        <a:t>42  </a:t>
                       </a:r>
                     </a:p>
                   </a:txBody>
@@ -19549,7 +19549,7 @@
                           </a:solidFill>
                           <a:latin typeface="Times New Roman"/>
                         </a:rPr>
-                        <a:t>969,681</a:t>
+                        <a:t>1,292,908</a:t>
                       </a:r>
                       <a:br/>
                       <a:r>
@@ -19559,7 +19559,7 @@
                           </a:solidFill>
                           <a:latin typeface="Times New Roman"/>
                         </a:rPr>
-                        <a:t>Cr. 96.97</a:t>
+                        <a:t>Cr. 129.29</a:t>
                       </a:r>
                     </a:p>
                   </a:txBody>
@@ -19602,7 +19602,7 @@
                           </a:solidFill>
                           <a:latin typeface="Times New Roman"/>
                         </a:rPr>
-                        <a:t>1,014,183</a:t>
+                        <a:t>1,100,220</a:t>
                       </a:r>
                       <a:br/>
                       <a:r>
@@ -19612,7 +19612,7 @@
                           </a:solidFill>
                           <a:latin typeface="Times New Roman"/>
                         </a:rPr>
-                        <a:t>Cr. 101.42</a:t>
+                        <a:t>Cr. 110.02</a:t>
                       </a:r>
                     </a:p>
                   </a:txBody>
@@ -19655,7 +19655,7 @@
                           </a:solidFill>
                           <a:latin typeface="Times New Roman"/>
                         </a:rPr>
-                        <a:t>44,502</a:t>
+                        <a:t>-192,688</a:t>
                       </a:r>
                       <a:br/>
                       <a:r>
@@ -19665,7 +19665,7 @@
                           </a:solidFill>
                           <a:latin typeface="Times New Roman"/>
                         </a:rPr>
-                        <a:t>Cr. 4.45</a:t>
+                        <a:t>Cr. -19.27</a:t>
                       </a:r>
                     </a:p>
                   </a:txBody>
@@ -19708,7 +19708,7 @@
                           </a:solidFill>
                           <a:latin typeface="Times New Roman"/>
                         </a:rPr>
-                        <a:t>105  </a:t>
+                        <a:t>85  </a:t>
                       </a:r>
                     </a:p>
                   </a:txBody>
@@ -19751,7 +19751,7 @@
                           </a:solidFill>
                           <a:latin typeface="Times New Roman"/>
                         </a:rPr>
-                        <a:t>2,864,541</a:t>
+                        <a:t>2,778,504</a:t>
                       </a:r>
                       <a:br/>
                       <a:r>
@@ -19761,7 +19761,7 @@
                           </a:solidFill>
                           <a:latin typeface="Times New Roman"/>
                         </a:rPr>
-                        <a:t>Cr. 286.45</a:t>
+                        <a:t>Cr. 277.85</a:t>
                       </a:r>
                     </a:p>
                   </a:txBody>
@@ -19804,7 +19804,7 @@
                           </a:solidFill>
                           <a:latin typeface="Times New Roman"/>
                         </a:rPr>
-                        <a:t>26  </a:t>
+                        <a:t>28  </a:t>
                       </a:r>
                     </a:p>
                   </a:txBody>
@@ -19945,7 +19945,7 @@
                           </a:solidFill>
                           <a:latin typeface="Times New Roman"/>
                         </a:rPr>
-                        <a:t>813,578</a:t>
+                        <a:t>1,084,770</a:t>
                       </a:r>
                       <a:br/>
                       <a:r>
@@ -19955,7 +19955,7 @@
                           </a:solidFill>
                           <a:latin typeface="Times New Roman"/>
                         </a:rPr>
-                        <a:t>Cr. 81.36</a:t>
+                        <a:t>Cr. 108.48</a:t>
                       </a:r>
                     </a:p>
                   </a:txBody>
@@ -19998,7 +19998,7 @@
                           </a:solidFill>
                           <a:latin typeface="Times New Roman"/>
                         </a:rPr>
-                        <a:t>966,861</a:t>
+                        <a:t>1,658,467</a:t>
                       </a:r>
                       <a:br/>
                       <a:r>
@@ -20008,7 +20008,7 @@
                           </a:solidFill>
                           <a:latin typeface="Times New Roman"/>
                         </a:rPr>
-                        <a:t>Cr. 96.69</a:t>
+                        <a:t>Cr. 165.85</a:t>
                       </a:r>
                     </a:p>
                   </a:txBody>
@@ -20051,7 +20051,7 @@
                           </a:solidFill>
                           <a:latin typeface="Times New Roman"/>
                         </a:rPr>
-                        <a:t>153,284</a:t>
+                        <a:t>573,697</a:t>
                       </a:r>
                       <a:br/>
                       <a:r>
@@ -20061,7 +20061,7 @@
                           </a:solidFill>
                           <a:latin typeface="Times New Roman"/>
                         </a:rPr>
-                        <a:t>Cr. 15.33</a:t>
+                        <a:t>Cr. 57.37</a:t>
                       </a:r>
                     </a:p>
                   </a:txBody>
@@ -20104,7 +20104,7 @@
                           </a:solidFill>
                           <a:latin typeface="Times New Roman"/>
                         </a:rPr>
-                        <a:t>119  </a:t>
+                        <a:t>153  </a:t>
                       </a:r>
                     </a:p>
                   </a:txBody>
@@ -20147,7 +20147,7 @@
                           </a:solidFill>
                           <a:latin typeface="Times New Roman"/>
                         </a:rPr>
-                        <a:t>2,287,449</a:t>
+                        <a:t>1,595,843</a:t>
                       </a:r>
                       <a:br/>
                       <a:r>
@@ -20157,7 +20157,7 @@
                           </a:solidFill>
                           <a:latin typeface="Times New Roman"/>
                         </a:rPr>
-                        <a:t>Cr. 228.74</a:t>
+                        <a:t>Cr. 159.58</a:t>
                       </a:r>
                     </a:p>
                   </a:txBody>
@@ -20200,7 +20200,7 @@
                           </a:solidFill>
                           <a:latin typeface="Times New Roman"/>
                         </a:rPr>
-                        <a:t>30  </a:t>
+                        <a:t>51  </a:t>
                       </a:r>
                     </a:p>
                   </a:txBody>
@@ -20341,7 +20341,7 @@
                           </a:solidFill>
                           <a:latin typeface="Times New Roman"/>
                         </a:rPr>
-                        <a:t>1,175,839</a:t>
+                        <a:t>1,567,785</a:t>
                       </a:r>
                       <a:br/>
                       <a:r>
@@ -20351,7 +20351,7 @@
                           </a:solidFill>
                           <a:latin typeface="Times New Roman"/>
                         </a:rPr>
-                        <a:t>Cr. 117.58</a:t>
+                        <a:t>Cr. 156.78</a:t>
                       </a:r>
                     </a:p>
                   </a:txBody>
@@ -20447,7 +20447,7 @@
                           </a:solidFill>
                           <a:latin typeface="Times New Roman"/>
                         </a:rPr>
-                        <a:t>631,235</a:t>
+                        <a:t>239,289</a:t>
                       </a:r>
                       <a:br/>
                       <a:r>
@@ -20457,7 +20457,7 @@
                           </a:solidFill>
                           <a:latin typeface="Times New Roman"/>
                         </a:rPr>
-                        <a:t>Cr. 63.12</a:t>
+                        <a:t>Cr. 23.93</a:t>
                       </a:r>
                     </a:p>
                   </a:txBody>
@@ -20500,7 +20500,7 @@
                           </a:solidFill>
                           <a:latin typeface="Times New Roman"/>
                         </a:rPr>
-                        <a:t>154  </a:t>
+                        <a:t>115  </a:t>
                       </a:r>
                     </a:p>
                   </a:txBody>
@@ -20737,7 +20737,7 @@
                           </a:solidFill>
                           <a:latin typeface="Times New Roman"/>
                         </a:rPr>
-                        <a:t>3,263,772</a:t>
+                        <a:t>4,351,696</a:t>
                       </a:r>
                       <a:br/>
                       <a:r>
@@ -20747,7 +20747,7 @@
                           </a:solidFill>
                           <a:latin typeface="Times New Roman"/>
                         </a:rPr>
-                        <a:t>Cr. 326.38</a:t>
+                        <a:t>Cr. 435.17</a:t>
                       </a:r>
                     </a:p>
                   </a:txBody>
@@ -20790,7 +20790,7 @@
                           </a:solidFill>
                           <a:latin typeface="Times New Roman"/>
                         </a:rPr>
-                        <a:t>4,419,278</a:t>
+                        <a:t>5,217,097</a:t>
                       </a:r>
                       <a:br/>
                       <a:r>
@@ -20800,7 +20800,7 @@
                           </a:solidFill>
                           <a:latin typeface="Times New Roman"/>
                         </a:rPr>
-                        <a:t>Cr. 441.93</a:t>
+                        <a:t>Cr. 521.71</a:t>
                       </a:r>
                     </a:p>
                   </a:txBody>
@@ -20843,7 +20843,7 @@
                           </a:solidFill>
                           <a:latin typeface="Times New Roman"/>
                         </a:rPr>
-                        <a:t>1,155,506</a:t>
+                        <a:t>865,401</a:t>
                       </a:r>
                       <a:br/>
                       <a:r>
@@ -20853,7 +20853,7 @@
                           </a:solidFill>
                           <a:latin typeface="Times New Roman"/>
                         </a:rPr>
-                        <a:t>Cr. 115.55</a:t>
+                        <a:t>Cr. 86.54</a:t>
                       </a:r>
                     </a:p>
                   </a:txBody>
@@ -20896,7 +20896,7 @@
                           </a:solidFill>
                           <a:latin typeface="Times New Roman"/>
                         </a:rPr>
-                        <a:t>135  </a:t>
+                        <a:t>120  </a:t>
                       </a:r>
                     </a:p>
                   </a:txBody>
@@ -20939,7 +20939,7 @@
                           </a:solidFill>
                           <a:latin typeface="Times New Roman"/>
                         </a:rPr>
-                        <a:t>8,635,811</a:t>
+                        <a:t>7,837,992</a:t>
                       </a:r>
                       <a:br/>
                       <a:r>
@@ -20949,7 +20949,7 @@
                           </a:solidFill>
                           <a:latin typeface="Times New Roman"/>
                         </a:rPr>
-                        <a:t>Cr. 863.58</a:t>
+                        <a:t>Cr. 783.80</a:t>
                       </a:r>
                     </a:p>
                   </a:txBody>
@@ -20992,7 +20992,7 @@
                           </a:solidFill>
                           <a:latin typeface="Times New Roman"/>
                         </a:rPr>
-                        <a:t>34  </a:t>
+                        <a:t>40  </a:t>
                       </a:r>
                     </a:p>
                   </a:txBody>
@@ -21563,7 +21563,7 @@
                           </a:solidFill>
                           <a:latin typeface="Times New Roman"/>
                         </a:rPr>
-                        <a:t>26,747</a:t>
+                        <a:t>49,143</a:t>
                       </a:r>
                       <a:br/>
                       <a:r>
@@ -21573,7 +21573,7 @@
                           </a:solidFill>
                           <a:latin typeface="Times New Roman"/>
                         </a:rPr>
-                        <a:t>Cr. 2.67</a:t>
+                        <a:t>Cr. 4.91</a:t>
                       </a:r>
                     </a:p>
                   </a:txBody>
@@ -21616,7 +21616,7 @@
                           </a:solidFill>
                           <a:latin typeface="Times New Roman"/>
                         </a:rPr>
-                        <a:t>-134,156</a:t>
+                        <a:t>-111,760</a:t>
                       </a:r>
                       <a:br/>
                       <a:r>
@@ -21626,7 +21626,7 @@
                           </a:solidFill>
                           <a:latin typeface="Times New Roman"/>
                         </a:rPr>
-                        <a:t>Cr. -13.42</a:t>
+                        <a:t>Cr. -11.18</a:t>
                       </a:r>
                     </a:p>
                   </a:txBody>
@@ -21669,7 +21669,7 @@
                           </a:solidFill>
                           <a:latin typeface="Times New Roman"/>
                         </a:rPr>
-                        <a:t>16.62</a:t>
+                        <a:t>30.54</a:t>
                       </a:r>
                     </a:p>
                   </a:txBody>
@@ -21853,7 +21853,7 @@
                           </a:solidFill>
                           <a:latin typeface="Times New Roman"/>
                         </a:rPr>
-                        <a:t>3,375</a:t>
+                        <a:t>3,682</a:t>
                       </a:r>
                       <a:br/>
                       <a:r>
@@ -21863,7 +21863,7 @@
                           </a:solidFill>
                           <a:latin typeface="Times New Roman"/>
                         </a:rPr>
-                        <a:t>Cr. 0.34</a:t>
+                        <a:t>Cr. 0.37</a:t>
                       </a:r>
                     </a:p>
                   </a:txBody>
@@ -21906,7 +21906,7 @@
                           </a:solidFill>
                           <a:latin typeface="Times New Roman"/>
                         </a:rPr>
-                        <a:t>-28,852</a:t>
+                        <a:t>-28,545</a:t>
                       </a:r>
                       <a:br/>
                       <a:r>
@@ -21916,7 +21916,7 @@
                           </a:solidFill>
                           <a:latin typeface="Times New Roman"/>
                         </a:rPr>
-                        <a:t>Cr. -2.89</a:t>
+                        <a:t>Cr. -2.85</a:t>
                       </a:r>
                     </a:p>
                   </a:txBody>
@@ -21959,7 +21959,7 @@
                           </a:solidFill>
                           <a:latin typeface="Times New Roman"/>
                         </a:rPr>
-                        <a:t>10.47</a:t>
+                        <a:t>11.43</a:t>
                       </a:r>
                     </a:p>
                   </a:txBody>
@@ -22143,7 +22143,7 @@
                           </a:solidFill>
                           <a:latin typeface="Times New Roman"/>
                         </a:rPr>
-                        <a:t>45,115</a:t>
+                        <a:t>49,669</a:t>
                       </a:r>
                       <a:br/>
                       <a:r>
@@ -22153,7 +22153,7 @@
                           </a:solidFill>
                           <a:latin typeface="Times New Roman"/>
                         </a:rPr>
-                        <a:t>Cr. 4.51</a:t>
+                        <a:t>Cr. 4.97</a:t>
                       </a:r>
                     </a:p>
                   </a:txBody>
@@ -22196,7 +22196,7 @@
                           </a:solidFill>
                           <a:latin typeface="Times New Roman"/>
                         </a:rPr>
-                        <a:t>-75,203</a:t>
+                        <a:t>-70,649</a:t>
                       </a:r>
                       <a:br/>
                       <a:r>
@@ -22206,7 +22206,7 @@
                           </a:solidFill>
                           <a:latin typeface="Times New Roman"/>
                         </a:rPr>
-                        <a:t>Cr. -7.52</a:t>
+                        <a:t>Cr. -7.06</a:t>
                       </a:r>
                     </a:p>
                   </a:txBody>
@@ -22249,7 +22249,7 @@
                           </a:solidFill>
                           <a:latin typeface="Times New Roman"/>
                         </a:rPr>
-                        <a:t>37.50</a:t>
+                        <a:t>41.28</a:t>
                       </a:r>
                     </a:p>
                   </a:txBody>
@@ -22433,7 +22433,7 @@
                           </a:solidFill>
                           <a:latin typeface="Times New Roman"/>
                         </a:rPr>
-                        <a:t>280,081</a:t>
+                        <a:t>314,675</a:t>
                       </a:r>
                       <a:br/>
                       <a:r>
@@ -22443,7 +22443,7 @@
                           </a:solidFill>
                           <a:latin typeface="Times New Roman"/>
                         </a:rPr>
-                        <a:t>Cr. 28.01</a:t>
+                        <a:t>Cr. 31.47</a:t>
                       </a:r>
                     </a:p>
                   </a:txBody>
@@ -22486,7 +22486,7 @@
                           </a:solidFill>
                           <a:latin typeface="Times New Roman"/>
                         </a:rPr>
-                        <a:t>-227,339</a:t>
+                        <a:t>-192,745</a:t>
                       </a:r>
                       <a:br/>
                       <a:r>
@@ -22496,7 +22496,7 @@
                           </a:solidFill>
                           <a:latin typeface="Times New Roman"/>
                         </a:rPr>
-                        <a:t>Cr. -22.73</a:t>
+                        <a:t>Cr. -19.27</a:t>
                       </a:r>
                     </a:p>
                   </a:txBody>
@@ -22539,7 +22539,7 @@
                           </a:solidFill>
                           <a:latin typeface="Times New Roman"/>
                         </a:rPr>
-                        <a:t>55.20</a:t>
+                        <a:t>62.01</a:t>
                       </a:r>
                     </a:p>
                   </a:txBody>
@@ -22723,7 +22723,7 @@
                           </a:solidFill>
                           <a:latin typeface="Times New Roman"/>
                         </a:rPr>
-                        <a:t>2,309,920</a:t>
+                        <a:t>2,356,170</a:t>
                       </a:r>
                       <a:br/>
                       <a:r>
@@ -22733,7 +22733,7 @@
                           </a:solidFill>
                           <a:latin typeface="Times New Roman"/>
                         </a:rPr>
-                        <a:t>Cr. 230.99</a:t>
+                        <a:t>Cr. 235.62</a:t>
                       </a:r>
                     </a:p>
                   </a:txBody>
@@ -22776,7 +22776,7 @@
                           </a:solidFill>
                           <a:latin typeface="Times New Roman"/>
                         </a:rPr>
-                        <a:t>-652,875</a:t>
+                        <a:t>-606,625</a:t>
                       </a:r>
                       <a:br/>
                       <a:r>
@@ -22786,7 +22786,7 @@
                           </a:solidFill>
                           <a:latin typeface="Times New Roman"/>
                         </a:rPr>
-                        <a:t>Cr. -65.29</a:t>
+                        <a:t>Cr. -60.66</a:t>
                       </a:r>
                     </a:p>
                   </a:txBody>
@@ -22829,7 +22829,7 @@
                           </a:solidFill>
                           <a:latin typeface="Times New Roman"/>
                         </a:rPr>
-                        <a:t>77.96</a:t>
+                        <a:t>79.53</a:t>
                       </a:r>
                     </a:p>
                   </a:txBody>
@@ -23013,7 +23013,7 @@
                           </a:solidFill>
                           <a:latin typeface="Times New Roman"/>
                         </a:rPr>
-                        <a:t>117,471</a:t>
+                        <a:t>135,953</a:t>
                       </a:r>
                       <a:br/>
                       <a:r>
@@ -23023,7 +23023,7 @@
                           </a:solidFill>
                           <a:latin typeface="Times New Roman"/>
                         </a:rPr>
-                        <a:t>Cr. 11.75</a:t>
+                        <a:t>Cr. 13.60</a:t>
                       </a:r>
                     </a:p>
                   </a:txBody>
@@ -23066,7 +23066,7 @@
                           </a:solidFill>
                           <a:latin typeface="Times New Roman"/>
                         </a:rPr>
-                        <a:t>-14,796</a:t>
+                        <a:t>3,686</a:t>
                       </a:r>
                       <a:br/>
                       <a:r>
@@ -23076,7 +23076,7 @@
                           </a:solidFill>
                           <a:latin typeface="Times New Roman"/>
                         </a:rPr>
-                        <a:t>Cr. -1.48</a:t>
+                        <a:t>Cr. 0.37</a:t>
                       </a:r>
                     </a:p>
                   </a:txBody>
@@ -23119,7 +23119,7 @@
                           </a:solidFill>
                           <a:latin typeface="Times New Roman"/>
                         </a:rPr>
-                        <a:t>88.81</a:t>
+                        <a:t>102.79</a:t>
                       </a:r>
                     </a:p>
                   </a:txBody>
@@ -23303,7 +23303,7 @@
                           </a:solidFill>
                           <a:latin typeface="Times New Roman"/>
                         </a:rPr>
-                        <a:t>83,786</a:t>
+                        <a:t>117,673</a:t>
                       </a:r>
                       <a:br/>
                       <a:r>
@@ -23313,7 +23313,7 @@
                           </a:solidFill>
                           <a:latin typeface="Times New Roman"/>
                         </a:rPr>
-                        <a:t>Cr. 8.38</a:t>
+                        <a:t>Cr. 11.77</a:t>
                       </a:r>
                     </a:p>
                   </a:txBody>
@@ -23356,7 +23356,7 @@
                           </a:solidFill>
                           <a:latin typeface="Times New Roman"/>
                         </a:rPr>
-                        <a:t>-439,057</a:t>
+                        <a:t>-405,170</a:t>
                       </a:r>
                       <a:br/>
                       <a:r>
@@ -23366,7 +23366,7 @@
                           </a:solidFill>
                           <a:latin typeface="Times New Roman"/>
                         </a:rPr>
-                        <a:t>Cr. -43.91</a:t>
+                        <a:t>Cr. -40.52</a:t>
                       </a:r>
                     </a:p>
                   </a:txBody>
@@ -23409,7 +23409,7 @@
                           </a:solidFill>
                           <a:latin typeface="Times New Roman"/>
                         </a:rPr>
-                        <a:t>16.03</a:t>
+                        <a:t>22.51</a:t>
                       </a:r>
                     </a:p>
                   </a:txBody>
@@ -23593,7 +23593,7 @@
                           </a:solidFill>
                           <a:latin typeface="Times New Roman"/>
                         </a:rPr>
-                        <a:t>77,718</a:t>
+                        <a:t>82,362</a:t>
                       </a:r>
                       <a:br/>
                       <a:r>
@@ -23603,7 +23603,7 @@
                           </a:solidFill>
                           <a:latin typeface="Times New Roman"/>
                         </a:rPr>
-                        <a:t>Cr. 7.77</a:t>
+                        <a:t>Cr. 8.24</a:t>
                       </a:r>
                     </a:p>
                   </a:txBody>
@@ -23646,7 +23646,7 @@
                           </a:solidFill>
                           <a:latin typeface="Times New Roman"/>
                         </a:rPr>
-                        <a:t>-230,125</a:t>
+                        <a:t>-225,481</a:t>
                       </a:r>
                       <a:br/>
                       <a:r>
@@ -23656,7 +23656,7 @@
                           </a:solidFill>
                           <a:latin typeface="Times New Roman"/>
                         </a:rPr>
-                        <a:t>Cr. -23.01</a:t>
+                        <a:t>Cr. -22.55</a:t>
                       </a:r>
                     </a:p>
                   </a:txBody>
@@ -23699,7 +23699,7 @@
                           </a:solidFill>
                           <a:latin typeface="Times New Roman"/>
                         </a:rPr>
-                        <a:t>25.25</a:t>
+                        <a:t>26.75</a:t>
                       </a:r>
                     </a:p>
                   </a:txBody>
@@ -24173,7 +24173,7 @@
                           </a:solidFill>
                           <a:latin typeface="Times New Roman"/>
                         </a:rPr>
-                        <a:t>1,919</a:t>
+                        <a:t>3,629</a:t>
                       </a:r>
                       <a:br/>
                       <a:r>
@@ -24183,7 +24183,7 @@
                           </a:solidFill>
                           <a:latin typeface="Times New Roman"/>
                         </a:rPr>
-                        <a:t>Cr. 0.19</a:t>
+                        <a:t>Cr. 0.36</a:t>
                       </a:r>
                     </a:p>
                   </a:txBody>
@@ -24226,7 +24226,7 @@
                           </a:solidFill>
                           <a:latin typeface="Times New Roman"/>
                         </a:rPr>
-                        <a:t>-11,275</a:t>
+                        <a:t>-9,565</a:t>
                       </a:r>
                       <a:br/>
                       <a:r>
@@ -24236,7 +24236,7 @@
                           </a:solidFill>
                           <a:latin typeface="Times New Roman"/>
                         </a:rPr>
-                        <a:t>Cr. -1.13</a:t>
+                        <a:t>Cr. -0.96</a:t>
                       </a:r>
                     </a:p>
                   </a:txBody>
@@ -24279,7 +24279,7 @@
                           </a:solidFill>
                           <a:latin typeface="Times New Roman"/>
                         </a:rPr>
-                        <a:t>14.54</a:t>
+                        <a:t>27.50</a:t>
                       </a:r>
                     </a:p>
                   </a:txBody>
@@ -24463,7 +24463,7 @@
                           </a:solidFill>
                           <a:latin typeface="Times New Roman"/>
                         </a:rPr>
-                        <a:t>2,426</a:t>
+                        <a:t>2,427</a:t>
                       </a:r>
                       <a:br/>
                       <a:r>
@@ -24516,7 +24516,7 @@
                           </a:solidFill>
                           <a:latin typeface="Times New Roman"/>
                         </a:rPr>
-                        <a:t>-51,276</a:t>
+                        <a:t>-51,275</a:t>
                       </a:r>
                       <a:br/>
                       <a:r>
@@ -24753,7 +24753,7 @@
                           </a:solidFill>
                           <a:latin typeface="Times New Roman"/>
                         </a:rPr>
-                        <a:t>22,047</a:t>
+                        <a:t>35,140</a:t>
                       </a:r>
                       <a:br/>
                       <a:r>
@@ -24763,7 +24763,7 @@
                           </a:solidFill>
                           <a:latin typeface="Times New Roman"/>
                         </a:rPr>
-                        <a:t>Cr. 2.20</a:t>
+                        <a:t>Cr. 3.51</a:t>
                       </a:r>
                     </a:p>
                   </a:txBody>
@@ -24806,7 +24806,7 @@
                           </a:solidFill>
                           <a:latin typeface="Times New Roman"/>
                         </a:rPr>
-                        <a:t>-75,453</a:t>
+                        <a:t>-62,360</a:t>
                       </a:r>
                       <a:br/>
                       <a:r>
@@ -24816,7 +24816,7 @@
                           </a:solidFill>
                           <a:latin typeface="Times New Roman"/>
                         </a:rPr>
-                        <a:t>Cr. -7.55</a:t>
+                        <a:t>Cr. -6.24</a:t>
                       </a:r>
                     </a:p>
                   </a:txBody>
@@ -24859,7 +24859,7 @@
                           </a:solidFill>
                           <a:latin typeface="Times New Roman"/>
                         </a:rPr>
-                        <a:t>22.61</a:t>
+                        <a:t>36.04</a:t>
                       </a:r>
                     </a:p>
                   </a:txBody>
@@ -25043,7 +25043,7 @@
                           </a:solidFill>
                           <a:latin typeface="Times New Roman"/>
                         </a:rPr>
-                        <a:t>125,504</a:t>
+                        <a:t>115,054</a:t>
                       </a:r>
                       <a:br/>
                       <a:r>
@@ -25053,7 +25053,7 @@
                           </a:solidFill>
                           <a:latin typeface="Times New Roman"/>
                         </a:rPr>
-                        <a:t>Cr. 12.55</a:t>
+                        <a:t>Cr. 11.51</a:t>
                       </a:r>
                     </a:p>
                   </a:txBody>
@@ -25096,7 +25096,7 @@
                           </a:solidFill>
                           <a:latin typeface="Times New Roman"/>
                         </a:rPr>
-                        <a:t>-185,408</a:t>
+                        <a:t>-195,858</a:t>
                       </a:r>
                       <a:br/>
                       <a:r>
@@ -25106,7 +25106,7 @@
                           </a:solidFill>
                           <a:latin typeface="Times New Roman"/>
                         </a:rPr>
-                        <a:t>Cr. -18.54</a:t>
+                        <a:t>Cr. -19.59</a:t>
                       </a:r>
                     </a:p>
                   </a:txBody>
@@ -25149,7 +25149,7 @@
                           </a:solidFill>
                           <a:latin typeface="Times New Roman"/>
                         </a:rPr>
-                        <a:t>40.37</a:t>
+                        <a:t>37.01</a:t>
                       </a:r>
                     </a:p>
                   </a:txBody>
@@ -25623,7 +25623,7 @@
                           </a:solidFill>
                           <a:latin typeface="Times New Roman"/>
                         </a:rPr>
-                        <a:t>71,352</a:t>
+                        <a:t>74,839</a:t>
                       </a:r>
                       <a:br/>
                       <a:r>
@@ -25633,7 +25633,7 @@
                           </a:solidFill>
                           <a:latin typeface="Times New Roman"/>
                         </a:rPr>
-                        <a:t>Cr. 7.14</a:t>
+                        <a:t>Cr. 7.48</a:t>
                       </a:r>
                     </a:p>
                   </a:txBody>
@@ -25676,7 +25676,7 @@
                           </a:solidFill>
                           <a:latin typeface="Times New Roman"/>
                         </a:rPr>
-                        <a:t>-244,381</a:t>
+                        <a:t>-240,894</a:t>
                       </a:r>
                       <a:br/>
                       <a:r>
@@ -25686,7 +25686,7 @@
                           </a:solidFill>
                           <a:latin typeface="Times New Roman"/>
                         </a:rPr>
-                        <a:t>Cr. -24.44</a:t>
+                        <a:t>Cr. -24.09</a:t>
                       </a:r>
                     </a:p>
                   </a:txBody>
@@ -25729,7 +25729,7 @@
                           </a:solidFill>
                           <a:latin typeface="Times New Roman"/>
                         </a:rPr>
-                        <a:t>22.60</a:t>
+                        <a:t>23.70</a:t>
                       </a:r>
                     </a:p>
                   </a:txBody>
@@ -26110,7 +26110,7 @@
                 </a:solidFill>
                 <a:latin typeface="Times New Roman"/>
               </a:rPr>
-              <a:t>Open Line FR Report (Rows 17-18)</a:t>
+              <a:t>Open Line FR Report (Rows 17-20)</a:t>
             </a:r>
           </a:p>
         </p:txBody>
@@ -26177,7 +26177,7 @@
                 <a:gridCol w="1787030"/>
                 <a:gridCol w="1090395"/>
               </a:tblGrid>
-              <a:tr h="1966000">
+              <a:tr h="1179600">
                 <a:tc>
                   <a:txBody>
                     <a:bodyPr wrap="square" anchor="ctr"/>
@@ -26437,7 +26437,7 @@
                   </a:tcPr>
                 </a:tc>
               </a:tr>
-              <a:tr h="1966000">
+              <a:tr h="1179600">
                 <a:tc>
                   <a:txBody>
                     <a:bodyPr wrap="square" anchor="ctr"/>
@@ -26727,7 +26727,7 @@
                   </a:tcPr>
                 </a:tc>
               </a:tr>
-              <a:tr h="1966000">
+              <a:tr h="1179600">
                 <a:tc>
                   <a:txBody>
                     <a:bodyPr wrap="square" anchor="ctr"/>
@@ -26784,6 +26784,586 @@
                           </a:solidFill>
                           <a:latin typeface="Times New Roman"/>
                         </a:rPr>
+                        <a:t>1. Sr. DEN (C )</a:t>
+                      </a:r>
+                    </a:p>
+                  </a:txBody>
+                  <a:tcPr marL="12000" marR="12000" marT="8000" marB="8000">
+                    <a:solidFill>
+                      <a:srgbClr val="C8D6E8"/>
+                    </a:solidFill>
+                    <a:lnL w="12700">
+                      <a:solidFill>
+                        <a:srgbClr val="000000"/>
+                      </a:solidFill>
+                    </a:lnL>
+                    <a:lnR w="12700">
+                      <a:solidFill>
+                        <a:srgbClr val="000000"/>
+                      </a:solidFill>
+                    </a:lnR>
+                    <a:lnT w="12700">
+                      <a:solidFill>
+                        <a:srgbClr val="000000"/>
+                      </a:solidFill>
+                    </a:lnT>
+                    <a:lnB w="12700">
+                      <a:solidFill>
+                        <a:srgbClr val="000000"/>
+                      </a:solidFill>
+                    </a:lnB>
+                  </a:tcPr>
+                </a:tc>
+                <a:tc>
+                  <a:txBody>
+                    <a:bodyPr wrap="square" anchor="ctr"/>
+                    <a:lstStyle/>
+                    <a:p>
+                      <a:pPr algn="ctr"/>
+                      <a:r>
+                        <a:rPr lang="en-US" sz="900" b="1">
+                          <a:solidFill>
+                            <a:srgbClr val="000000"/>
+                          </a:solidFill>
+                          <a:latin typeface="Times New Roman"/>
+                        </a:rPr>
+                        <a:t>0</a:t>
+                      </a:r>
+                      <a:br/>
+                      <a:r>
+                        <a:rPr lang="en-US" sz="900" b="1">
+                          <a:solidFill>
+                            <a:srgbClr val="000000"/>
+                          </a:solidFill>
+                          <a:latin typeface="Times New Roman"/>
+                        </a:rPr>
+                        <a:t>Cr. 0.00</a:t>
+                      </a:r>
+                    </a:p>
+                  </a:txBody>
+                  <a:tcPr marL="12000" marR="12000" marT="8000" marB="8000">
+                    <a:solidFill>
+                      <a:srgbClr val="C8D6E8"/>
+                    </a:solidFill>
+                    <a:lnL w="12700">
+                      <a:solidFill>
+                        <a:srgbClr val="000000"/>
+                      </a:solidFill>
+                    </a:lnL>
+                    <a:lnR w="12700">
+                      <a:solidFill>
+                        <a:srgbClr val="000000"/>
+                      </a:solidFill>
+                    </a:lnR>
+                    <a:lnT w="12700">
+                      <a:solidFill>
+                        <a:srgbClr val="000000"/>
+                      </a:solidFill>
+                    </a:lnT>
+                    <a:lnB w="12700">
+                      <a:solidFill>
+                        <a:srgbClr val="000000"/>
+                      </a:solidFill>
+                    </a:lnB>
+                  </a:tcPr>
+                </a:tc>
+                <a:tc>
+                  <a:txBody>
+                    <a:bodyPr wrap="square" anchor="ctr"/>
+                    <a:lstStyle/>
+                    <a:p>
+                      <a:pPr algn="ctr"/>
+                      <a:r>
+                        <a:rPr lang="en-US" sz="900" b="1">
+                          <a:solidFill>
+                            <a:srgbClr val="000000"/>
+                          </a:solidFill>
+                          <a:latin typeface="Times New Roman"/>
+                        </a:rPr>
+                        <a:t>0</a:t>
+                      </a:r>
+                      <a:br/>
+                      <a:r>
+                        <a:rPr lang="en-US" sz="900" b="1">
+                          <a:solidFill>
+                            <a:srgbClr val="000000"/>
+                          </a:solidFill>
+                          <a:latin typeface="Times New Roman"/>
+                        </a:rPr>
+                        <a:t>Cr. 0.00</a:t>
+                      </a:r>
+                    </a:p>
+                  </a:txBody>
+                  <a:tcPr marL="12000" marR="12000" marT="8000" marB="8000">
+                    <a:solidFill>
+                      <a:srgbClr val="C8D6E8"/>
+                    </a:solidFill>
+                    <a:lnL w="12700">
+                      <a:solidFill>
+                        <a:srgbClr val="000000"/>
+                      </a:solidFill>
+                    </a:lnL>
+                    <a:lnR w="12700">
+                      <a:solidFill>
+                        <a:srgbClr val="000000"/>
+                      </a:solidFill>
+                    </a:lnR>
+                    <a:lnT w="12700">
+                      <a:solidFill>
+                        <a:srgbClr val="000000"/>
+                      </a:solidFill>
+                    </a:lnT>
+                    <a:lnB w="12700">
+                      <a:solidFill>
+                        <a:srgbClr val="000000"/>
+                      </a:solidFill>
+                    </a:lnB>
+                  </a:tcPr>
+                </a:tc>
+                <a:tc>
+                  <a:txBody>
+                    <a:bodyPr wrap="square" anchor="ctr"/>
+                    <a:lstStyle/>
+                    <a:p>
+                      <a:pPr algn="ctr"/>
+                      <a:r>
+                        <a:rPr lang="en-US" sz="900" b="1">
+                          <a:solidFill>
+                            <a:srgbClr val="000000"/>
+                          </a:solidFill>
+                          <a:latin typeface="Times New Roman"/>
+                        </a:rPr>
+                        <a:t>0</a:t>
+                      </a:r>
+                      <a:br/>
+                      <a:r>
+                        <a:rPr lang="en-US" sz="900" b="1">
+                          <a:solidFill>
+                            <a:srgbClr val="000000"/>
+                          </a:solidFill>
+                          <a:latin typeface="Times New Roman"/>
+                        </a:rPr>
+                        <a:t>Cr. 0.00</a:t>
+                      </a:r>
+                    </a:p>
+                  </a:txBody>
+                  <a:tcPr marL="12000" marR="12000" marT="8000" marB="8000">
+                    <a:solidFill>
+                      <a:srgbClr val="C8D6E8"/>
+                    </a:solidFill>
+                    <a:lnL w="12700">
+                      <a:solidFill>
+                        <a:srgbClr val="000000"/>
+                      </a:solidFill>
+                    </a:lnL>
+                    <a:lnR w="12700">
+                      <a:solidFill>
+                        <a:srgbClr val="000000"/>
+                      </a:solidFill>
+                    </a:lnR>
+                    <a:lnT w="12700">
+                      <a:solidFill>
+                        <a:srgbClr val="000000"/>
+                      </a:solidFill>
+                    </a:lnT>
+                    <a:lnB w="12700">
+                      <a:solidFill>
+                        <a:srgbClr val="000000"/>
+                      </a:solidFill>
+                    </a:lnB>
+                  </a:tcPr>
+                </a:tc>
+                <a:tc>
+                  <a:txBody>
+                    <a:bodyPr wrap="square" anchor="ctr"/>
+                    <a:lstStyle/>
+                    <a:p>
+                      <a:pPr algn="ctr"/>
+                      <a:r>
+                        <a:rPr lang="en-US" sz="900" b="1">
+                          <a:solidFill>
+                            <a:srgbClr val="000000"/>
+                          </a:solidFill>
+                          <a:latin typeface="Times New Roman"/>
+                        </a:rPr>
+                        <a:t>0.00</a:t>
+                      </a:r>
+                    </a:p>
+                  </a:txBody>
+                  <a:tcPr marL="12000" marR="12000" marT="8000" marB="8000">
+                    <a:solidFill>
+                      <a:srgbClr val="C8D6E8"/>
+                    </a:solidFill>
+                    <a:lnL w="12700">
+                      <a:solidFill>
+                        <a:srgbClr val="000000"/>
+                      </a:solidFill>
+                    </a:lnL>
+                    <a:lnR w="12700">
+                      <a:solidFill>
+                        <a:srgbClr val="000000"/>
+                      </a:solidFill>
+                    </a:lnR>
+                    <a:lnT w="12700">
+                      <a:solidFill>
+                        <a:srgbClr val="000000"/>
+                      </a:solidFill>
+                    </a:lnT>
+                    <a:lnB w="12700">
+                      <a:solidFill>
+                        <a:srgbClr val="000000"/>
+                      </a:solidFill>
+                    </a:lnB>
+                  </a:tcPr>
+                </a:tc>
+              </a:tr>
+              <a:tr h="1179600">
+                <a:tc>
+                  <a:txBody>
+                    <a:bodyPr wrap="square" anchor="ctr"/>
+                    <a:lstStyle/>
+                    <a:p>
+                      <a:pPr algn="ctr"/>
+                      <a:r>
+                        <a:rPr lang="en-US" sz="900" b="1">
+                          <a:solidFill>
+                            <a:srgbClr val="000000"/>
+                          </a:solidFill>
+                          <a:latin typeface="Times New Roman"/>
+                        </a:rPr>
+                        <a:t>Total</a:t>
+                      </a:r>
+                    </a:p>
+                  </a:txBody>
+                  <a:tcPr marL="12000" marR="12000" marT="8000" marB="8000">
+                    <a:solidFill>
+                      <a:srgbClr val="C8D6E8"/>
+                    </a:solidFill>
+                    <a:lnL w="12700">
+                      <a:solidFill>
+                        <a:srgbClr val="000000"/>
+                      </a:solidFill>
+                    </a:lnL>
+                    <a:lnR w="12700">
+                      <a:solidFill>
+                        <a:srgbClr val="000000"/>
+                      </a:solidFill>
+                    </a:lnR>
+                    <a:lnT w="12700">
+                      <a:solidFill>
+                        <a:srgbClr val="000000"/>
+                      </a:solidFill>
+                    </a:lnT>
+                    <a:lnB w="12700">
+                      <a:solidFill>
+                        <a:srgbClr val="000000"/>
+                      </a:solidFill>
+                    </a:lnB>
+                  </a:tcPr>
+                </a:tc>
+                <a:tc>
+                  <a:txBody>
+                    <a:bodyPr wrap="square" anchor="ctr"/>
+                    <a:lstStyle/>
+                    <a:p>
+                      <a:pPr algn="l"/>
+                      <a:r>
+                        <a:rPr lang="en-US" sz="900" b="1">
+                          <a:solidFill>
+                            <a:srgbClr val="000000"/>
+                          </a:solidFill>
+                          <a:latin typeface="Times New Roman"/>
+                        </a:rPr>
+                        <a:t>2. Sr. DEE (G &amp; TRD)</a:t>
+                      </a:r>
+                    </a:p>
+                  </a:txBody>
+                  <a:tcPr marL="12000" marR="12000" marT="8000" marB="8000">
+                    <a:solidFill>
+                      <a:srgbClr val="C8D6E8"/>
+                    </a:solidFill>
+                    <a:lnL w="12700">
+                      <a:solidFill>
+                        <a:srgbClr val="000000"/>
+                      </a:solidFill>
+                    </a:lnL>
+                    <a:lnR w="12700">
+                      <a:solidFill>
+                        <a:srgbClr val="000000"/>
+                      </a:solidFill>
+                    </a:lnR>
+                    <a:lnT w="12700">
+                      <a:solidFill>
+                        <a:srgbClr val="000000"/>
+                      </a:solidFill>
+                    </a:lnT>
+                    <a:lnB w="12700">
+                      <a:solidFill>
+                        <a:srgbClr val="000000"/>
+                      </a:solidFill>
+                    </a:lnB>
+                  </a:tcPr>
+                </a:tc>
+                <a:tc>
+                  <a:txBody>
+                    <a:bodyPr wrap="square" anchor="ctr"/>
+                    <a:lstStyle/>
+                    <a:p>
+                      <a:pPr algn="ctr"/>
+                      <a:r>
+                        <a:rPr lang="en-US" sz="900" b="1">
+                          <a:solidFill>
+                            <a:srgbClr val="000000"/>
+                          </a:solidFill>
+                          <a:latin typeface="Times New Roman"/>
+                        </a:rPr>
+                        <a:t>0</a:t>
+                      </a:r>
+                      <a:br/>
+                      <a:r>
+                        <a:rPr lang="en-US" sz="900" b="1">
+                          <a:solidFill>
+                            <a:srgbClr val="000000"/>
+                          </a:solidFill>
+                          <a:latin typeface="Times New Roman"/>
+                        </a:rPr>
+                        <a:t>Cr. 0.00</a:t>
+                      </a:r>
+                    </a:p>
+                  </a:txBody>
+                  <a:tcPr marL="12000" marR="12000" marT="8000" marB="8000">
+                    <a:solidFill>
+                      <a:srgbClr val="C8D6E8"/>
+                    </a:solidFill>
+                    <a:lnL w="12700">
+                      <a:solidFill>
+                        <a:srgbClr val="000000"/>
+                      </a:solidFill>
+                    </a:lnL>
+                    <a:lnR w="12700">
+                      <a:solidFill>
+                        <a:srgbClr val="000000"/>
+                      </a:solidFill>
+                    </a:lnR>
+                    <a:lnT w="12700">
+                      <a:solidFill>
+                        <a:srgbClr val="000000"/>
+                      </a:solidFill>
+                    </a:lnT>
+                    <a:lnB w="12700">
+                      <a:solidFill>
+                        <a:srgbClr val="000000"/>
+                      </a:solidFill>
+                    </a:lnB>
+                  </a:tcPr>
+                </a:tc>
+                <a:tc>
+                  <a:txBody>
+                    <a:bodyPr wrap="square" anchor="ctr"/>
+                    <a:lstStyle/>
+                    <a:p>
+                      <a:pPr algn="ctr"/>
+                      <a:r>
+                        <a:rPr lang="en-US" sz="900" b="1">
+                          <a:solidFill>
+                            <a:srgbClr val="000000"/>
+                          </a:solidFill>
+                          <a:latin typeface="Times New Roman"/>
+                        </a:rPr>
+                        <a:t>0</a:t>
+                      </a:r>
+                      <a:br/>
+                      <a:r>
+                        <a:rPr lang="en-US" sz="900" b="1">
+                          <a:solidFill>
+                            <a:srgbClr val="000000"/>
+                          </a:solidFill>
+                          <a:latin typeface="Times New Roman"/>
+                        </a:rPr>
+                        <a:t>Cr. 0.00</a:t>
+                      </a:r>
+                    </a:p>
+                  </a:txBody>
+                  <a:tcPr marL="12000" marR="12000" marT="8000" marB="8000">
+                    <a:solidFill>
+                      <a:srgbClr val="C8D6E8"/>
+                    </a:solidFill>
+                    <a:lnL w="12700">
+                      <a:solidFill>
+                        <a:srgbClr val="000000"/>
+                      </a:solidFill>
+                    </a:lnL>
+                    <a:lnR w="12700">
+                      <a:solidFill>
+                        <a:srgbClr val="000000"/>
+                      </a:solidFill>
+                    </a:lnR>
+                    <a:lnT w="12700">
+                      <a:solidFill>
+                        <a:srgbClr val="000000"/>
+                      </a:solidFill>
+                    </a:lnT>
+                    <a:lnB w="12700">
+                      <a:solidFill>
+                        <a:srgbClr val="000000"/>
+                      </a:solidFill>
+                    </a:lnB>
+                  </a:tcPr>
+                </a:tc>
+                <a:tc>
+                  <a:txBody>
+                    <a:bodyPr wrap="square" anchor="ctr"/>
+                    <a:lstStyle/>
+                    <a:p>
+                      <a:pPr algn="ctr"/>
+                      <a:r>
+                        <a:rPr lang="en-US" sz="900" b="1">
+                          <a:solidFill>
+                            <a:srgbClr val="000000"/>
+                          </a:solidFill>
+                          <a:latin typeface="Times New Roman"/>
+                        </a:rPr>
+                        <a:t>0</a:t>
+                      </a:r>
+                      <a:br/>
+                      <a:r>
+                        <a:rPr lang="en-US" sz="900" b="1">
+                          <a:solidFill>
+                            <a:srgbClr val="000000"/>
+                          </a:solidFill>
+                          <a:latin typeface="Times New Roman"/>
+                        </a:rPr>
+                        <a:t>Cr. 0.00</a:t>
+                      </a:r>
+                    </a:p>
+                  </a:txBody>
+                  <a:tcPr marL="12000" marR="12000" marT="8000" marB="8000">
+                    <a:solidFill>
+                      <a:srgbClr val="C8D6E8"/>
+                    </a:solidFill>
+                    <a:lnL w="12700">
+                      <a:solidFill>
+                        <a:srgbClr val="000000"/>
+                      </a:solidFill>
+                    </a:lnL>
+                    <a:lnR w="12700">
+                      <a:solidFill>
+                        <a:srgbClr val="000000"/>
+                      </a:solidFill>
+                    </a:lnR>
+                    <a:lnT w="12700">
+                      <a:solidFill>
+                        <a:srgbClr val="000000"/>
+                      </a:solidFill>
+                    </a:lnT>
+                    <a:lnB w="12700">
+                      <a:solidFill>
+                        <a:srgbClr val="000000"/>
+                      </a:solidFill>
+                    </a:lnB>
+                  </a:tcPr>
+                </a:tc>
+                <a:tc>
+                  <a:txBody>
+                    <a:bodyPr wrap="square" anchor="ctr"/>
+                    <a:lstStyle/>
+                    <a:p>
+                      <a:pPr algn="ctr"/>
+                      <a:r>
+                        <a:rPr lang="en-US" sz="900" b="1">
+                          <a:solidFill>
+                            <a:srgbClr val="000000"/>
+                          </a:solidFill>
+                          <a:latin typeface="Times New Roman"/>
+                        </a:rPr>
+                        <a:t>0.00</a:t>
+                      </a:r>
+                    </a:p>
+                  </a:txBody>
+                  <a:tcPr marL="12000" marR="12000" marT="8000" marB="8000">
+                    <a:solidFill>
+                      <a:srgbClr val="C8D6E8"/>
+                    </a:solidFill>
+                    <a:lnL w="12700">
+                      <a:solidFill>
+                        <a:srgbClr val="000000"/>
+                      </a:solidFill>
+                    </a:lnL>
+                    <a:lnR w="12700">
+                      <a:solidFill>
+                        <a:srgbClr val="000000"/>
+                      </a:solidFill>
+                    </a:lnR>
+                    <a:lnT w="12700">
+                      <a:solidFill>
+                        <a:srgbClr val="000000"/>
+                      </a:solidFill>
+                    </a:lnT>
+                    <a:lnB w="12700">
+                      <a:solidFill>
+                        <a:srgbClr val="000000"/>
+                      </a:solidFill>
+                    </a:lnB>
+                  </a:tcPr>
+                </a:tc>
+              </a:tr>
+              <a:tr h="1179600">
+                <a:tc>
+                  <a:txBody>
+                    <a:bodyPr wrap="square" anchor="ctr"/>
+                    <a:lstStyle/>
+                    <a:p>
+                      <a:pPr algn="ctr"/>
+                      <a:r>
+                        <a:rPr lang="en-US" sz="900" b="1">
+                          <a:solidFill>
+                            <a:srgbClr val="000000"/>
+                          </a:solidFill>
+                          <a:latin typeface="Times New Roman"/>
+                        </a:rPr>
+                        <a:t>Total</a:t>
+                      </a:r>
+                    </a:p>
+                  </a:txBody>
+                  <a:tcPr marL="12000" marR="12000" marT="8000" marB="8000">
+                    <a:solidFill>
+                      <a:srgbClr val="C8D6E8"/>
+                    </a:solidFill>
+                    <a:lnL w="12700">
+                      <a:solidFill>
+                        <a:srgbClr val="000000"/>
+                      </a:solidFill>
+                    </a:lnL>
+                    <a:lnR w="12700">
+                      <a:solidFill>
+                        <a:srgbClr val="000000"/>
+                      </a:solidFill>
+                    </a:lnR>
+                    <a:lnT w="12700">
+                      <a:solidFill>
+                        <a:srgbClr val="000000"/>
+                      </a:solidFill>
+                    </a:lnT>
+                    <a:lnB w="12700">
+                      <a:solidFill>
+                        <a:srgbClr val="000000"/>
+                      </a:solidFill>
+                    </a:lnB>
+                  </a:tcPr>
+                </a:tc>
+                <a:tc>
+                  <a:txBody>
+                    <a:bodyPr wrap="square" anchor="ctr"/>
+                    <a:lstStyle/>
+                    <a:p>
+                      <a:pPr algn="l"/>
+                      <a:r>
+                        <a:rPr lang="en-US" sz="900" b="1">
+                          <a:solidFill>
+                            <a:srgbClr val="000000"/>
+                          </a:solidFill>
+                          <a:latin typeface="Times New Roman"/>
+                        </a:rPr>
                         <a:t/>
                       </a:r>
                     </a:p>
@@ -26880,7 +27460,7 @@
                           </a:solidFill>
                           <a:latin typeface="Times New Roman"/>
                         </a:rPr>
-                        <a:t>3,167,461</a:t>
+                        <a:t>3,340,416</a:t>
                       </a:r>
                       <a:br/>
                       <a:r>
@@ -26890,7 +27470,7 @@
                           </a:solidFill>
                           <a:latin typeface="Times New Roman"/>
                         </a:rPr>
-                        <a:t>Cr. 316.75</a:t>
+                        <a:t>Cr. 334.04</a:t>
                       </a:r>
                     </a:p>
                   </a:txBody>
@@ -26933,7 +27513,7 @@
                           </a:solidFill>
                           <a:latin typeface="Times New Roman"/>
                         </a:rPr>
-                        <a:t>-2,440,240</a:t>
+                        <a:t>-2,267,285</a:t>
                       </a:r>
                       <a:br/>
                       <a:r>
@@ -26943,7 +27523,7 @@
                           </a:solidFill>
                           <a:latin typeface="Times New Roman"/>
                         </a:rPr>
-                        <a:t>Cr. -244.02</a:t>
+                        <a:t>Cr. -226.73</a:t>
                       </a:r>
                     </a:p>
                   </a:txBody>
@@ -26986,7 +27566,7 @@
                           </a:solidFill>
                           <a:latin typeface="Times New Roman"/>
                         </a:rPr>
-                        <a:t>56.48</a:t>
+                        <a:t>59.57</a:t>
                       </a:r>
                     </a:p>
                   </a:txBody>
@@ -27514,7 +28094,7 @@
                           </a:solidFill>
                           <a:latin typeface="Times New Roman"/>
                         </a:rPr>
-                        <a:t>262,411</a:t>
+                        <a:t>296,990</a:t>
                       </a:r>
                       <a:br/>
                       <a:r>
@@ -27524,7 +28104,7 @@
                           </a:solidFill>
                           <a:latin typeface="Times New Roman"/>
                         </a:rPr>
-                        <a:t>Cr. 26.24</a:t>
+                        <a:t>Cr. 29.70</a:t>
                       </a:r>
                     </a:p>
                   </a:txBody>
@@ -27567,7 +28147,7 @@
                           </a:solidFill>
                           <a:latin typeface="Times New Roman"/>
                         </a:rPr>
-                        <a:t>755,942</a:t>
+                        <a:t>721,363</a:t>
                       </a:r>
                       <a:br/>
                       <a:r>
@@ -27577,7 +28157,7 @@
                           </a:solidFill>
                           <a:latin typeface="Times New Roman"/>
                         </a:rPr>
-                        <a:t>Cr. 75.59</a:t>
+                        <a:t>Cr. 72.14</a:t>
                       </a:r>
                     </a:p>
                   </a:txBody>
@@ -27620,7 +28200,7 @@
                           </a:solidFill>
                           <a:latin typeface="Times New Roman"/>
                         </a:rPr>
-                        <a:t>25.77</a:t>
+                        <a:t>29.16</a:t>
                       </a:r>
                     </a:p>
                   </a:txBody>
@@ -27663,7 +28243,7 @@
                           </a:solidFill>
                           <a:latin typeface="Times New Roman"/>
                         </a:rPr>
-                        <a:t>74.23</a:t>
+                        <a:t>70.84</a:t>
                       </a:r>
                     </a:p>
                   </a:txBody>
@@ -28094,7 +28674,7 @@
                           </a:solidFill>
                           <a:latin typeface="Times New Roman"/>
                         </a:rPr>
-                        <a:t>8,107</a:t>
+                        <a:t>8,703</a:t>
                       </a:r>
                       <a:br/>
                       <a:r>
@@ -28104,7 +28684,7 @@
                           </a:solidFill>
                           <a:latin typeface="Times New Roman"/>
                         </a:rPr>
-                        <a:t>Cr. 0.81</a:t>
+                        <a:t>Cr. 0.87</a:t>
                       </a:r>
                     </a:p>
                   </a:txBody>
@@ -28147,7 +28727,7 @@
                           </a:solidFill>
                           <a:latin typeface="Times New Roman"/>
                         </a:rPr>
-                        <a:t>122,485</a:t>
+                        <a:t>121,889</a:t>
                       </a:r>
                       <a:br/>
                       <a:r>
@@ -28157,7 +28737,7 @@
                           </a:solidFill>
                           <a:latin typeface="Times New Roman"/>
                         </a:rPr>
-                        <a:t>Cr. 12.25</a:t>
+                        <a:t>Cr. 12.19</a:t>
                       </a:r>
                     </a:p>
                   </a:txBody>
@@ -28200,7 +28780,7 @@
                           </a:solidFill>
                           <a:latin typeface="Times New Roman"/>
                         </a:rPr>
-                        <a:t>6.21</a:t>
+                        <a:t>6.66</a:t>
                       </a:r>
                     </a:p>
                   </a:txBody>
@@ -28243,7 +28823,7 @@
                           </a:solidFill>
                           <a:latin typeface="Times New Roman"/>
                         </a:rPr>
-                        <a:t>93.79</a:t>
+                        <a:t>93.34</a:t>
                       </a:r>
                     </a:p>
                   </a:txBody>
@@ -28674,7 +29254,7 @@
                           </a:solidFill>
                           <a:latin typeface="Times New Roman"/>
                         </a:rPr>
-                        <a:t>2,386,001</a:t>
+                        <a:t>2,463,326</a:t>
                       </a:r>
                       <a:br/>
                       <a:r>
@@ -28684,7 +29264,7 @@
                           </a:solidFill>
                           <a:latin typeface="Times New Roman"/>
                         </a:rPr>
-                        <a:t>Cr. 238.60</a:t>
+                        <a:t>Cr. 246.33</a:t>
                       </a:r>
                     </a:p>
                   </a:txBody>
@@ -28727,7 +29307,7 @@
                           </a:solidFill>
                           <a:latin typeface="Times New Roman"/>
                         </a:rPr>
-                        <a:t>731,514</a:t>
+                        <a:t>654,189</a:t>
                       </a:r>
                       <a:br/>
                       <a:r>
@@ -28737,7 +29317,7 @@
                           </a:solidFill>
                           <a:latin typeface="Times New Roman"/>
                         </a:rPr>
-                        <a:t>Cr. 73.15</a:t>
+                        <a:t>Cr. 65.42</a:t>
                       </a:r>
                     </a:p>
                   </a:txBody>
@@ -28780,7 +29360,7 @@
                           </a:solidFill>
                           <a:latin typeface="Times New Roman"/>
                         </a:rPr>
-                        <a:t>76.54</a:t>
+                        <a:t>79.02</a:t>
                       </a:r>
                     </a:p>
                   </a:txBody>
@@ -28823,7 +29403,7 @@
                           </a:solidFill>
                           <a:latin typeface="Times New Roman"/>
                         </a:rPr>
-                        <a:t>23.46</a:t>
+                        <a:t>20.98</a:t>
                       </a:r>
                     </a:p>
                   </a:txBody>
@@ -29254,7 +29834,7 @@
                           </a:solidFill>
                           <a:latin typeface="Times New Roman"/>
                         </a:rPr>
-                        <a:t>498,296</a:t>
+                        <a:t>558,751</a:t>
                       </a:r>
                       <a:br/>
                       <a:r>
@@ -29264,7 +29844,7 @@
                           </a:solidFill>
                           <a:latin typeface="Times New Roman"/>
                         </a:rPr>
-                        <a:t>Cr. 49.83</a:t>
+                        <a:t>Cr. 55.88</a:t>
                       </a:r>
                     </a:p>
                   </a:txBody>
@@ -29307,7 +29887,7 @@
                           </a:solidFill>
                           <a:latin typeface="Times New Roman"/>
                         </a:rPr>
-                        <a:t>802,713</a:t>
+                        <a:t>742,258</a:t>
                       </a:r>
                       <a:br/>
                       <a:r>
@@ -29317,7 +29897,7 @@
                           </a:solidFill>
                           <a:latin typeface="Times New Roman"/>
                         </a:rPr>
-                        <a:t>Cr. 80.27</a:t>
+                        <a:t>Cr. 74.23</a:t>
                       </a:r>
                     </a:p>
                   </a:txBody>
@@ -29360,7 +29940,7 @@
                           </a:solidFill>
                           <a:latin typeface="Times New Roman"/>
                         </a:rPr>
-                        <a:t>38.30</a:t>
+                        <a:t>42.95</a:t>
                       </a:r>
                     </a:p>
                   </a:txBody>
@@ -29403,7 +29983,7 @@
                           </a:solidFill>
                           <a:latin typeface="Times New Roman"/>
                         </a:rPr>
-                        <a:t>61.70</a:t>
+                        <a:t>57.05</a:t>
                       </a:r>
                     </a:p>
                   </a:txBody>

</xml_diff>

<commit_message>
Align exports with portal BP calculations
</commit_message>
<xml_diff>
--- a/exports/Moradabad_Division_DRM_Budget_FR_Analysis.pptx
+++ b/exports/Moradabad_Division_DRM_Budget_FR_Analysis.pptx
@@ -6936,7 +6936,7 @@
                           </a:solidFill>
                           <a:latin typeface="Times New Roman"/>
                         </a:rPr>
-                        <a:t>213,841</a:t>
+                        <a:t>240,031</a:t>
                       </a:r>
                       <a:br/>
                       <a:r>
@@ -6946,7 +6946,7 @@
                           </a:solidFill>
                           <a:latin typeface="Times New Roman"/>
                         </a:rPr>
-                        <a:t>Cr. 21.38</a:t>
+                        <a:t>Cr. 24.00</a:t>
                       </a:r>
                     </a:p>
                   </a:txBody>
@@ -7042,7 +7042,7 @@
                           </a:solidFill>
                           <a:latin typeface="Times New Roman"/>
                         </a:rPr>
-                        <a:t>18,753</a:t>
+                        <a:t>-7,437</a:t>
                       </a:r>
                       <a:br/>
                       <a:r>
@@ -7052,7 +7052,7 @@
                           </a:solidFill>
                           <a:latin typeface="Times New Roman"/>
                         </a:rPr>
-                        <a:t>Cr. 1.88</a:t>
+                        <a:t>Cr. -0.74</a:t>
                       </a:r>
                     </a:p>
                   </a:txBody>
@@ -7095,13 +7095,13 @@
                           </a:solidFill>
                           <a:latin typeface="Times New Roman"/>
                         </a:rPr>
-                        <a:t>109</a:t>
-                      </a:r>
-                    </a:p>
-                  </a:txBody>
-                  <a:tcPr marL="12000" marR="12000" marT="8000" marB="8000">
-                    <a:solidFill>
-                      <a:srgbClr val="FCE4E4"/>
+                        <a:t>97</a:t>
+                      </a:r>
+                    </a:p>
+                  </a:txBody>
+                  <a:tcPr marL="12000" marR="12000" marT="8000" marB="8000">
+                    <a:solidFill>
+                      <a:srgbClr val="FFF2CC"/>
                     </a:solidFill>
                     <a:lnL w="12700">
                       <a:solidFill>
@@ -7375,7 +7375,7 @@
                           </a:solidFill>
                           <a:latin typeface="Times New Roman"/>
                         </a:rPr>
-                        <a:t>1,202,967</a:t>
+                        <a:t>1,177,984</a:t>
                       </a:r>
                       <a:br/>
                       <a:r>
@@ -7385,7 +7385,7 @@
                           </a:solidFill>
                           <a:latin typeface="Times New Roman"/>
                         </a:rPr>
-                        <a:t>Cr. 120.30</a:t>
+                        <a:t>Cr. 117.80</a:t>
                       </a:r>
                     </a:p>
                   </a:txBody>
@@ -7481,7 +7481,7 @@
                           </a:solidFill>
                           <a:latin typeface="Times New Roman"/>
                         </a:rPr>
-                        <a:t>264,851</a:t>
+                        <a:t>289,834</a:t>
                       </a:r>
                       <a:br/>
                       <a:r>
@@ -7491,7 +7491,7 @@
                           </a:solidFill>
                           <a:latin typeface="Times New Roman"/>
                         </a:rPr>
-                        <a:t>Cr. 26.49</a:t>
+                        <a:t>Cr. 28.98</a:t>
                       </a:r>
                     </a:p>
                   </a:txBody>
@@ -7534,7 +7534,7 @@
                           </a:solidFill>
                           <a:latin typeface="Times New Roman"/>
                         </a:rPr>
-                        <a:t>122</a:t>
+                        <a:t>125</a:t>
                       </a:r>
                     </a:p>
                   </a:txBody>
@@ -7814,7 +7814,7 @@
                           </a:solidFill>
                           <a:latin typeface="Times New Roman"/>
                         </a:rPr>
-                        <a:t>621,614</a:t>
+                        <a:t>923,741</a:t>
                       </a:r>
                       <a:br/>
                       <a:r>
@@ -7824,7 +7824,7 @@
                           </a:solidFill>
                           <a:latin typeface="Times New Roman"/>
                         </a:rPr>
-                        <a:t>Cr. 62.16</a:t>
+                        <a:t>Cr. 92.37</a:t>
                       </a:r>
                     </a:p>
                   </a:txBody>
@@ -7920,7 +7920,7 @@
                           </a:solidFill>
                           <a:latin typeface="Times New Roman"/>
                         </a:rPr>
-                        <a:t>160,418</a:t>
+                        <a:t>-141,709</a:t>
                       </a:r>
                       <a:br/>
                       <a:r>
@@ -7930,7 +7930,7 @@
                           </a:solidFill>
                           <a:latin typeface="Times New Roman"/>
                         </a:rPr>
-                        <a:t>Cr. 16.04</a:t>
+                        <a:t>Cr. -14.17</a:t>
                       </a:r>
                     </a:p>
                   </a:txBody>
@@ -7973,13 +7973,13 @@
                           </a:solidFill>
                           <a:latin typeface="Times New Roman"/>
                         </a:rPr>
-                        <a:t>126</a:t>
-                      </a:r>
-                    </a:p>
-                  </a:txBody>
-                  <a:tcPr marL="12000" marR="12000" marT="8000" marB="8000">
-                    <a:solidFill>
-                      <a:srgbClr val="FCE4E4"/>
+                        <a:t>85</a:t>
+                      </a:r>
+                    </a:p>
+                  </a:txBody>
+                  <a:tcPr marL="12000" marR="12000" marT="8000" marB="8000">
+                    <a:solidFill>
+                      <a:srgbClr val="FFF2CC"/>
                     </a:solidFill>
                     <a:lnL w="12700">
                       <a:solidFill>
@@ -8253,7 +8253,7 @@
                           </a:solidFill>
                           <a:latin typeface="Times New Roman"/>
                         </a:rPr>
-                        <a:t>451,194</a:t>
+                        <a:t>413,960</a:t>
                       </a:r>
                       <a:br/>
                       <a:r>
@@ -8263,7 +8263,7 @@
                           </a:solidFill>
                           <a:latin typeface="Times New Roman"/>
                         </a:rPr>
-                        <a:t>Cr. 45.12</a:t>
+                        <a:t>Cr. 41.40</a:t>
                       </a:r>
                     </a:p>
                   </a:txBody>
@@ -8359,7 +8359,7 @@
                           </a:solidFill>
                           <a:latin typeface="Times New Roman"/>
                         </a:rPr>
-                        <a:t>271,412</a:t>
+                        <a:t>308,646</a:t>
                       </a:r>
                       <a:br/>
                       <a:r>
@@ -8369,7 +8369,7 @@
                           </a:solidFill>
                           <a:latin typeface="Times New Roman"/>
                         </a:rPr>
-                        <a:t>Cr. 27.14</a:t>
+                        <a:t>Cr. 30.86</a:t>
                       </a:r>
                     </a:p>
                   </a:txBody>
@@ -8412,7 +8412,7 @@
                           </a:solidFill>
                           <a:latin typeface="Times New Roman"/>
                         </a:rPr>
-                        <a:t>160</a:t>
+                        <a:t>175</a:t>
                       </a:r>
                     </a:p>
                   </a:txBody>
@@ -8692,7 +8692,7 @@
                           </a:solidFill>
                           <a:latin typeface="Times New Roman"/>
                         </a:rPr>
-                        <a:t>686,650</a:t>
+                        <a:t>694,140</a:t>
                       </a:r>
                       <a:br/>
                       <a:r>
@@ -8702,7 +8702,7 @@
                           </a:solidFill>
                           <a:latin typeface="Times New Roman"/>
                         </a:rPr>
-                        <a:t>Cr. 68.67</a:t>
+                        <a:t>Cr. 69.41</a:t>
                       </a:r>
                     </a:p>
                   </a:txBody>
@@ -8798,7 +8798,7 @@
                           </a:solidFill>
                           <a:latin typeface="Times New Roman"/>
                         </a:rPr>
-                        <a:t>113,462</a:t>
+                        <a:t>105,972</a:t>
                       </a:r>
                       <a:br/>
                       <a:r>
@@ -8808,7 +8808,7 @@
                           </a:solidFill>
                           <a:latin typeface="Times New Roman"/>
                         </a:rPr>
-                        <a:t>Cr. 11.35</a:t>
+                        <a:t>Cr. 10.60</a:t>
                       </a:r>
                     </a:p>
                   </a:txBody>
@@ -8851,7 +8851,7 @@
                           </a:solidFill>
                           <a:latin typeface="Times New Roman"/>
                         </a:rPr>
-                        <a:t>117</a:t>
+                        <a:t>115</a:t>
                       </a:r>
                     </a:p>
                   </a:txBody>
@@ -9131,7 +9131,7 @@
                           </a:solidFill>
                           <a:latin typeface="Times New Roman"/>
                         </a:rPr>
-                        <a:t>1,117,522</a:t>
+                        <a:t>1,217,272</a:t>
                       </a:r>
                       <a:br/>
                       <a:r>
@@ -9141,7 +9141,7 @@
                           </a:solidFill>
                           <a:latin typeface="Times New Roman"/>
                         </a:rPr>
-                        <a:t>Cr. 111.75</a:t>
+                        <a:t>Cr. 121.73</a:t>
                       </a:r>
                     </a:p>
                   </a:txBody>
@@ -9237,7 +9237,7 @@
                           </a:solidFill>
                           <a:latin typeface="Times New Roman"/>
                         </a:rPr>
-                        <a:t>445,441</a:t>
+                        <a:t>345,691</a:t>
                       </a:r>
                       <a:br/>
                       <a:r>
@@ -9247,7 +9247,7 @@
                           </a:solidFill>
                           <a:latin typeface="Times New Roman"/>
                         </a:rPr>
-                        <a:t>Cr. 44.54</a:t>
+                        <a:t>Cr. 34.57</a:t>
                       </a:r>
                     </a:p>
                   </a:txBody>
@@ -9290,7 +9290,7 @@
                           </a:solidFill>
                           <a:latin typeface="Times New Roman"/>
                         </a:rPr>
-                        <a:t>140</a:t>
+                        <a:t>128</a:t>
                       </a:r>
                     </a:p>
                   </a:txBody>
@@ -9570,7 +9570,7 @@
                           </a:solidFill>
                           <a:latin typeface="Times New Roman"/>
                         </a:rPr>
-                        <a:t>1,476,255</a:t>
+                        <a:t>1,511,191</a:t>
                       </a:r>
                       <a:br/>
                       <a:r>
@@ -9580,7 +9580,7 @@
                           </a:solidFill>
                           <a:latin typeface="Times New Roman"/>
                         </a:rPr>
-                        <a:t>Cr. 147.63</a:t>
+                        <a:t>Cr. 151.12</a:t>
                       </a:r>
                     </a:p>
                   </a:txBody>
@@ -9676,7 +9676,7 @@
                           </a:solidFill>
                           <a:latin typeface="Times New Roman"/>
                         </a:rPr>
-                        <a:t>301,046</a:t>
+                        <a:t>266,110</a:t>
                       </a:r>
                       <a:br/>
                       <a:r>
@@ -9686,7 +9686,7 @@
                           </a:solidFill>
                           <a:latin typeface="Times New Roman"/>
                         </a:rPr>
-                        <a:t>Cr. 30.10</a:t>
+                        <a:t>Cr. 26.61</a:t>
                       </a:r>
                     </a:p>
                   </a:txBody>
@@ -9729,7 +9729,7 @@
                           </a:solidFill>
                           <a:latin typeface="Times New Roman"/>
                         </a:rPr>
-                        <a:t>120</a:t>
+                        <a:t>118</a:t>
                       </a:r>
                     </a:p>
                   </a:txBody>
@@ -10009,7 +10009,7 @@
                           </a:solidFill>
                           <a:latin typeface="Times New Roman"/>
                         </a:rPr>
-                        <a:t>3,869,069</a:t>
+                        <a:t>3,862,305</a:t>
                       </a:r>
                       <a:br/>
                       <a:r>
@@ -10019,7 +10019,7 @@
                           </a:solidFill>
                           <a:latin typeface="Times New Roman"/>
                         </a:rPr>
-                        <a:t>Cr. 386.91</a:t>
+                        <a:t>Cr. 386.23</a:t>
                       </a:r>
                     </a:p>
                   </a:txBody>
@@ -10115,7 +10115,7 @@
                           </a:solidFill>
                           <a:latin typeface="Times New Roman"/>
                         </a:rPr>
-                        <a:t>-323,855</a:t>
+                        <a:t>-317,091</a:t>
                       </a:r>
                       <a:br/>
                       <a:r>
@@ -10125,7 +10125,7 @@
                           </a:solidFill>
                           <a:latin typeface="Times New Roman"/>
                         </a:rPr>
-                        <a:t>Cr. -32.39</a:t>
+                        <a:t>Cr. -31.71</a:t>
                       </a:r>
                     </a:p>
                   </a:txBody>
@@ -10448,7 +10448,7 @@
                           </a:solidFill>
                           <a:latin typeface="Times New Roman"/>
                         </a:rPr>
-                        <a:t>464,277</a:t>
+                        <a:t>598,674</a:t>
                       </a:r>
                       <a:br/>
                       <a:r>
@@ -10458,7 +10458,7 @@
                           </a:solidFill>
                           <a:latin typeface="Times New Roman"/>
                         </a:rPr>
-                        <a:t>Cr. 46.43</a:t>
+                        <a:t>Cr. 59.87</a:t>
                       </a:r>
                     </a:p>
                   </a:txBody>
@@ -10554,7 +10554,7 @@
                           </a:solidFill>
                           <a:latin typeface="Times New Roman"/>
                         </a:rPr>
-                        <a:t>343,473</a:t>
+                        <a:t>209,076</a:t>
                       </a:r>
                       <a:br/>
                       <a:r>
@@ -10564,7 +10564,7 @@
                           </a:solidFill>
                           <a:latin typeface="Times New Roman"/>
                         </a:rPr>
-                        <a:t>Cr. 34.35</a:t>
+                        <a:t>Cr. 20.91</a:t>
                       </a:r>
                     </a:p>
                   </a:txBody>
@@ -10607,7 +10607,7 @@
                           </a:solidFill>
                           <a:latin typeface="Times New Roman"/>
                         </a:rPr>
-                        <a:t>174</a:t>
+                        <a:t>135</a:t>
                       </a:r>
                     </a:p>
                   </a:txBody>
@@ -10887,7 +10887,7 @@
                           </a:solidFill>
                           <a:latin typeface="Times New Roman"/>
                         </a:rPr>
-                        <a:t>331,546</a:t>
+                        <a:t>325,688</a:t>
                       </a:r>
                       <a:br/>
                       <a:r>
@@ -10897,7 +10897,7 @@
                           </a:solidFill>
                           <a:latin typeface="Times New Roman"/>
                         </a:rPr>
-                        <a:t>Cr. 33.15</a:t>
+                        <a:t>Cr. 32.57</a:t>
                       </a:r>
                     </a:p>
                   </a:txBody>
@@ -10993,7 +10993,7 @@
                           </a:solidFill>
                           <a:latin typeface="Times New Roman"/>
                         </a:rPr>
-                        <a:t>24,320</a:t>
+                        <a:t>30,178</a:t>
                       </a:r>
                       <a:br/>
                       <a:r>
@@ -11003,7 +11003,7 @@
                           </a:solidFill>
                           <a:latin typeface="Times New Roman"/>
                         </a:rPr>
-                        <a:t>Cr. 2.43</a:t>
+                        <a:t>Cr. 3.02</a:t>
                       </a:r>
                     </a:p>
                   </a:txBody>
@@ -11046,7 +11046,7 @@
                           </a:solidFill>
                           <a:latin typeface="Times New Roman"/>
                         </a:rPr>
-                        <a:t>107</a:t>
+                        <a:t>109</a:t>
                       </a:r>
                     </a:p>
                   </a:txBody>
@@ -11326,7 +11326,7 @@
                           </a:solidFill>
                           <a:latin typeface="Times New Roman"/>
                         </a:rPr>
-                        <a:t>430,356</a:t>
+                        <a:t>388,570</a:t>
                       </a:r>
                       <a:br/>
                       <a:r>
@@ -11336,7 +11336,7 @@
                           </a:solidFill>
                           <a:latin typeface="Times New Roman"/>
                         </a:rPr>
-                        <a:t>Cr. 43.04</a:t>
+                        <a:t>Cr. 38.86</a:t>
                       </a:r>
                     </a:p>
                   </a:txBody>
@@ -11432,7 +11432,7 @@
                           </a:solidFill>
                           <a:latin typeface="Times New Roman"/>
                         </a:rPr>
-                        <a:t>-4,678</a:t>
+                        <a:t>37,108</a:t>
                       </a:r>
                       <a:br/>
                       <a:r>
@@ -11442,7 +11442,7 @@
                           </a:solidFill>
                           <a:latin typeface="Times New Roman"/>
                         </a:rPr>
-                        <a:t>Cr. -0.47</a:t>
+                        <a:t>Cr. 3.71</a:t>
                       </a:r>
                     </a:p>
                   </a:txBody>
@@ -11485,13 +11485,13 @@
                           </a:solidFill>
                           <a:latin typeface="Times New Roman"/>
                         </a:rPr>
-                        <a:t>99</a:t>
-                      </a:r>
-                    </a:p>
-                  </a:txBody>
-                  <a:tcPr marL="12000" marR="12000" marT="8000" marB="8000">
-                    <a:solidFill>
-                      <a:srgbClr val="FFF2CC"/>
+                        <a:t>110</a:t>
+                      </a:r>
+                    </a:p>
+                  </a:txBody>
+                  <a:tcPr marL="12000" marR="12000" marT="8000" marB="8000">
+                    <a:solidFill>
+                      <a:srgbClr val="FCE4E4"/>
                     </a:solidFill>
                     <a:lnL w="12700">
                       <a:solidFill>
@@ -11765,7 +11765,7 @@
                           </a:solidFill>
                           <a:latin typeface="Times New Roman"/>
                         </a:rPr>
-                        <a:t>10,865,291</a:t>
+                        <a:t>11,353,556</a:t>
                       </a:r>
                       <a:br/>
                       <a:r>
@@ -11775,7 +11775,7 @@
                           </a:solidFill>
                           <a:latin typeface="Times New Roman"/>
                         </a:rPr>
-                        <a:t>Cr. 1086.53</a:t>
+                        <a:t>Cr. 1135.36</a:t>
                       </a:r>
                     </a:p>
                   </a:txBody>
@@ -11871,7 +11871,7 @@
                           </a:solidFill>
                           <a:latin typeface="Times New Roman"/>
                         </a:rPr>
-                        <a:t>1,614,643</a:t>
+                        <a:t>1,126,378</a:t>
                       </a:r>
                       <a:br/>
                       <a:r>
@@ -11881,7 +11881,7 @@
                           </a:solidFill>
                           <a:latin typeface="Times New Roman"/>
                         </a:rPr>
-                        <a:t>Cr. 161.46</a:t>
+                        <a:t>Cr. 112.64</a:t>
                       </a:r>
                     </a:p>
                   </a:txBody>
@@ -11924,7 +11924,7 @@
                           </a:solidFill>
                           <a:latin typeface="Times New Roman"/>
                         </a:rPr>
-                        <a:t>115</a:t>
+                        <a:t>110</a:t>
                       </a:r>
                     </a:p>
                   </a:txBody>
@@ -12204,7 +12204,7 @@
                           </a:solidFill>
                           <a:latin typeface="Times New Roman"/>
                         </a:rPr>
-                        <a:t>-4,348</a:t>
+                        <a:t>1,362,799</a:t>
                       </a:r>
                       <a:br/>
                       <a:r>
@@ -12214,7 +12214,7 @@
                           </a:solidFill>
                           <a:latin typeface="Times New Roman"/>
                         </a:rPr>
-                        <a:t>Cr. -0.43</a:t>
+                        <a:t>Cr. 136.28</a:t>
                       </a:r>
                     </a:p>
                   </a:txBody>
@@ -12310,7 +12310,7 @@
                           </a:solidFill>
                           <a:latin typeface="Times New Roman"/>
                         </a:rPr>
-                        <a:t>1,573,380</a:t>
+                        <a:t>206,233</a:t>
                       </a:r>
                       <a:br/>
                       <a:r>
@@ -12320,7 +12320,7 @@
                           </a:solidFill>
                           <a:latin typeface="Times New Roman"/>
                         </a:rPr>
-                        <a:t>Cr. 157.34</a:t>
+                        <a:t>Cr. 20.62</a:t>
                       </a:r>
                     </a:p>
                   </a:txBody>
@@ -12363,7 +12363,7 @@
                           </a:solidFill>
                           <a:latin typeface="Times New Roman"/>
                         </a:rPr>
-                        <a:t>-36084</a:t>
+                        <a:t>115</a:t>
                       </a:r>
                     </a:p>
                   </a:txBody>
@@ -13215,7 +13215,7 @@
                           </a:solidFill>
                           <a:latin typeface="Times New Roman"/>
                         </a:rPr>
-                        <a:t>2,235,470</a:t>
+                        <a:t>2,249,064</a:t>
                       </a:r>
                       <a:br/>
                       <a:r>
@@ -13225,7 +13225,7 @@
                           </a:solidFill>
                           <a:latin typeface="Times New Roman"/>
                         </a:rPr>
-                        <a:t>Cr. 223.55</a:t>
+                        <a:t>Cr. 224.91</a:t>
                       </a:r>
                     </a:p>
                   </a:txBody>
@@ -13321,7 +13321,7 @@
                           </a:solidFill>
                           <a:latin typeface="Times New Roman"/>
                         </a:rPr>
-                        <a:t>219,422</a:t>
+                        <a:t>205,828</a:t>
                       </a:r>
                       <a:br/>
                       <a:r>
@@ -13331,7 +13331,7 @@
                           </a:solidFill>
                           <a:latin typeface="Times New Roman"/>
                         </a:rPr>
-                        <a:t>Cr. 21.94</a:t>
+                        <a:t>Cr. 20.58</a:t>
                       </a:r>
                     </a:p>
                   </a:txBody>
@@ -13374,7 +13374,7 @@
                           </a:solidFill>
                           <a:latin typeface="Times New Roman"/>
                         </a:rPr>
-                        <a:t>110</a:t>
+                        <a:t>109</a:t>
                       </a:r>
                     </a:p>
                   </a:txBody>
@@ -13611,7 +13611,7 @@
                           </a:solidFill>
                           <a:latin typeface="Times New Roman"/>
                         </a:rPr>
-                        <a:t>1,366,818</a:t>
+                        <a:t>1,359,404</a:t>
                       </a:r>
                       <a:br/>
                       <a:r>
@@ -13621,7 +13621,7 @@
                           </a:solidFill>
                           <a:latin typeface="Times New Roman"/>
                         </a:rPr>
-                        <a:t>Cr. 136.68</a:t>
+                        <a:t>Cr. 135.94</a:t>
                       </a:r>
                     </a:p>
                   </a:txBody>
@@ -13717,7 +13717,7 @@
                           </a:solidFill>
                           <a:latin typeface="Times New Roman"/>
                         </a:rPr>
-                        <a:t>213,027</a:t>
+                        <a:t>220,441</a:t>
                       </a:r>
                       <a:br/>
                       <a:r>
@@ -13727,7 +13727,7 @@
                           </a:solidFill>
                           <a:latin typeface="Times New Roman"/>
                         </a:rPr>
-                        <a:t>Cr. 21.30</a:t>
+                        <a:t>Cr. 22.04</a:t>
                       </a:r>
                     </a:p>
                   </a:txBody>
@@ -14007,7 +14007,7 @@
                           </a:solidFill>
                           <a:latin typeface="Times New Roman"/>
                         </a:rPr>
-                        <a:t>95,030</a:t>
+                        <a:t>0</a:t>
                       </a:r>
                       <a:br/>
                       <a:r>
@@ -14017,7 +14017,7 @@
                           </a:solidFill>
                           <a:latin typeface="Times New Roman"/>
                         </a:rPr>
-                        <a:t>Cr. 9.50</a:t>
+                        <a:t>Cr. 0.00</a:t>
                       </a:r>
                     </a:p>
                   </a:txBody>
@@ -14113,7 +14113,7 @@
                           </a:solidFill>
                           <a:latin typeface="Times New Roman"/>
                         </a:rPr>
-                        <a:t>-94,949</a:t>
+                        <a:t>81</a:t>
                       </a:r>
                       <a:br/>
                       <a:r>
@@ -14123,7 +14123,7 @@
                           </a:solidFill>
                           <a:latin typeface="Times New Roman"/>
                         </a:rPr>
-                        <a:t>Cr. -9.49</a:t>
+                        <a:t>Cr. 0.01</a:t>
                       </a:r>
                     </a:p>
                   </a:txBody>
@@ -14403,7 +14403,7 @@
                           </a:solidFill>
                           <a:latin typeface="Times New Roman"/>
                         </a:rPr>
-                        <a:t>258,733</a:t>
+                        <a:t>268,852</a:t>
                       </a:r>
                       <a:br/>
                       <a:r>
@@ -14413,7 +14413,7 @@
                           </a:solidFill>
                           <a:latin typeface="Times New Roman"/>
                         </a:rPr>
-                        <a:t>Cr. 25.87</a:t>
+                        <a:t>Cr. 26.89</a:t>
                       </a:r>
                     </a:p>
                   </a:txBody>
@@ -14509,7 +14509,7 @@
                           </a:solidFill>
                           <a:latin typeface="Times New Roman"/>
                         </a:rPr>
-                        <a:t>11,258</a:t>
+                        <a:t>1,139</a:t>
                       </a:r>
                       <a:br/>
                       <a:r>
@@ -14519,7 +14519,7 @@
                           </a:solidFill>
                           <a:latin typeface="Times New Roman"/>
                         </a:rPr>
-                        <a:t>Cr. 1.13</a:t>
+                        <a:t>Cr. 0.11</a:t>
                       </a:r>
                     </a:p>
                   </a:txBody>
@@ -14562,13 +14562,13 @@
                           </a:solidFill>
                           <a:latin typeface="Times New Roman"/>
                         </a:rPr>
-                        <a:t>104</a:t>
-                      </a:r>
-                    </a:p>
-                  </a:txBody>
-                  <a:tcPr marL="12000" marR="12000" marT="8000" marB="8000">
-                    <a:solidFill>
-                      <a:srgbClr val="FCE4E4"/>
+                        <a:t>100</a:t>
+                      </a:r>
+                    </a:p>
+                  </a:txBody>
+                  <a:tcPr marL="12000" marR="12000" marT="8000" marB="8000">
+                    <a:solidFill>
+                      <a:srgbClr val="FFF2CC"/>
                     </a:solidFill>
                     <a:lnL w="12700">
                       <a:solidFill>
@@ -14799,7 +14799,7 @@
                           </a:solidFill>
                           <a:latin typeface="Times New Roman"/>
                         </a:rPr>
-                        <a:t>165,536</a:t>
+                        <a:t>167,312</a:t>
                       </a:r>
                       <a:br/>
                       <a:r>
@@ -14809,7 +14809,7 @@
                           </a:solidFill>
                           <a:latin typeface="Times New Roman"/>
                         </a:rPr>
-                        <a:t>Cr. 16.55</a:t>
+                        <a:t>Cr. 16.73</a:t>
                       </a:r>
                     </a:p>
                   </a:txBody>
@@ -14905,7 +14905,7 @@
                           </a:solidFill>
                           <a:latin typeface="Times New Roman"/>
                         </a:rPr>
-                        <a:t>7,971</a:t>
+                        <a:t>6,195</a:t>
                       </a:r>
                       <a:br/>
                       <a:r>
@@ -14915,7 +14915,7 @@
                           </a:solidFill>
                           <a:latin typeface="Times New Roman"/>
                         </a:rPr>
-                        <a:t>Cr. 0.80</a:t>
+                        <a:t>Cr. 0.62</a:t>
                       </a:r>
                     </a:p>
                   </a:txBody>
@@ -14958,7 +14958,7 @@
                           </a:solidFill>
                           <a:latin typeface="Times New Roman"/>
                         </a:rPr>
-                        <a:t>105</a:t>
+                        <a:t>104</a:t>
                       </a:r>
                     </a:p>
                   </a:txBody>
@@ -15195,7 +15195,7 @@
                           </a:solidFill>
                           <a:latin typeface="Times New Roman"/>
                         </a:rPr>
-                        <a:t>226,732</a:t>
+                        <a:t>255,207</a:t>
                       </a:r>
                       <a:br/>
                       <a:r>
@@ -15205,7 +15205,7 @@
                           </a:solidFill>
                           <a:latin typeface="Times New Roman"/>
                         </a:rPr>
-                        <a:t>Cr. 22.67</a:t>
+                        <a:t>Cr. 25.52</a:t>
                       </a:r>
                     </a:p>
                   </a:txBody>
@@ -15301,7 +15301,7 @@
                           </a:solidFill>
                           <a:latin typeface="Times New Roman"/>
                         </a:rPr>
-                        <a:t>63,750</a:t>
+                        <a:t>35,275</a:t>
                       </a:r>
                       <a:br/>
                       <a:r>
@@ -15311,7 +15311,7 @@
                           </a:solidFill>
                           <a:latin typeface="Times New Roman"/>
                         </a:rPr>
-                        <a:t>Cr. 6.37</a:t>
+                        <a:t>Cr. 3.53</a:t>
                       </a:r>
                     </a:p>
                   </a:txBody>
@@ -15354,7 +15354,7 @@
                           </a:solidFill>
                           <a:latin typeface="Times New Roman"/>
                         </a:rPr>
-                        <a:t>128</a:t>
+                        <a:t>114</a:t>
                       </a:r>
                     </a:p>
                   </a:txBody>
@@ -15591,7 +15591,7 @@
                           </a:solidFill>
                           <a:latin typeface="Times New Roman"/>
                         </a:rPr>
-                        <a:t>25,767</a:t>
+                        <a:t>26,924</a:t>
                       </a:r>
                       <a:br/>
                       <a:r>
@@ -15601,7 +15601,7 @@
                           </a:solidFill>
                           <a:latin typeface="Times New Roman"/>
                         </a:rPr>
-                        <a:t>Cr. 2.58</a:t>
+                        <a:t>Cr. 2.69</a:t>
                       </a:r>
                     </a:p>
                   </a:txBody>
@@ -15697,7 +15697,7 @@
                           </a:solidFill>
                           <a:latin typeface="Times New Roman"/>
                         </a:rPr>
-                        <a:t>28,778</a:t>
+                        <a:t>27,621</a:t>
                       </a:r>
                       <a:br/>
                       <a:r>
@@ -15707,7 +15707,7 @@
                           </a:solidFill>
                           <a:latin typeface="Times New Roman"/>
                         </a:rPr>
-                        <a:t>Cr. 2.88</a:t>
+                        <a:t>Cr. 2.76</a:t>
                       </a:r>
                     </a:p>
                   </a:txBody>
@@ -15750,7 +15750,7 @@
                           </a:solidFill>
                           <a:latin typeface="Times New Roman"/>
                         </a:rPr>
-                        <a:t>212</a:t>
+                        <a:t>203</a:t>
                       </a:r>
                     </a:p>
                   </a:txBody>
@@ -15987,7 +15987,7 @@
                           </a:solidFill>
                           <a:latin typeface="Times New Roman"/>
                         </a:rPr>
-                        <a:t>69,971</a:t>
+                        <a:t>69,543</a:t>
                       </a:r>
                       <a:br/>
                       <a:r>
@@ -15997,7 +15997,7 @@
                           </a:solidFill>
                           <a:latin typeface="Times New Roman"/>
                         </a:rPr>
-                        <a:t>Cr. 7.00</a:t>
+                        <a:t>Cr. 6.95</a:t>
                       </a:r>
                     </a:p>
                   </a:txBody>
@@ -16093,7 +16093,7 @@
                           </a:solidFill>
                           <a:latin typeface="Times New Roman"/>
                         </a:rPr>
-                        <a:t>28,051</a:t>
+                        <a:t>28,479</a:t>
                       </a:r>
                       <a:br/>
                       <a:r>
@@ -16103,7 +16103,7 @@
                           </a:solidFill>
                           <a:latin typeface="Times New Roman"/>
                         </a:rPr>
-                        <a:t>Cr. 2.81</a:t>
+                        <a:t>Cr. 2.85</a:t>
                       </a:r>
                     </a:p>
                   </a:txBody>
@@ -16146,7 +16146,7 @@
                           </a:solidFill>
                           <a:latin typeface="Times New Roman"/>
                         </a:rPr>
-                        <a:t>140</a:t>
+                        <a:t>141</a:t>
                       </a:r>
                     </a:p>
                   </a:txBody>
@@ -16383,7 +16383,7 @@
                           </a:solidFill>
                           <a:latin typeface="Times New Roman"/>
                         </a:rPr>
-                        <a:t>175,944</a:t>
+                        <a:t>273,477</a:t>
                       </a:r>
                       <a:br/>
                       <a:r>
@@ -16393,7 +16393,7 @@
                           </a:solidFill>
                           <a:latin typeface="Times New Roman"/>
                         </a:rPr>
-                        <a:t>Cr. 17.59</a:t>
+                        <a:t>Cr. 27.35</a:t>
                       </a:r>
                     </a:p>
                   </a:txBody>
@@ -16489,7 +16489,7 @@
                           </a:solidFill>
                           <a:latin typeface="Times New Roman"/>
                         </a:rPr>
-                        <a:t>74,849</a:t>
+                        <a:t>-22,684</a:t>
                       </a:r>
                       <a:br/>
                       <a:r>
@@ -16499,7 +16499,7 @@
                           </a:solidFill>
                           <a:latin typeface="Times New Roman"/>
                         </a:rPr>
-                        <a:t>Cr. 7.48</a:t>
+                        <a:t>Cr. -2.27</a:t>
                       </a:r>
                     </a:p>
                   </a:txBody>
@@ -16542,13 +16542,13 @@
                           </a:solidFill>
                           <a:latin typeface="Times New Roman"/>
                         </a:rPr>
-                        <a:t>143</a:t>
-                      </a:r>
-                    </a:p>
-                  </a:txBody>
-                  <a:tcPr marL="12000" marR="12000" marT="8000" marB="8000">
-                    <a:solidFill>
-                      <a:srgbClr val="FCE4E4"/>
+                        <a:t>92</a:t>
+                      </a:r>
+                    </a:p>
+                  </a:txBody>
+                  <a:tcPr marL="12000" marR="12000" marT="8000" marB="8000">
+                    <a:solidFill>
+                      <a:srgbClr val="FFF2CC"/>
                     </a:solidFill>
                     <a:lnL w="12700">
                       <a:solidFill>
@@ -16779,7 +16779,7 @@
                           </a:solidFill>
                           <a:latin typeface="Times New Roman"/>
                         </a:rPr>
-                        <a:t>5,349</a:t>
+                        <a:t>5,665</a:t>
                       </a:r>
                       <a:br/>
                       <a:r>
@@ -16789,7 +16789,7 @@
                           </a:solidFill>
                           <a:latin typeface="Times New Roman"/>
                         </a:rPr>
-                        <a:t>Cr. 0.53</a:t>
+                        <a:t>Cr. 0.57</a:t>
                       </a:r>
                     </a:p>
                   </a:txBody>
@@ -16885,7 +16885,7 @@
                           </a:solidFill>
                           <a:latin typeface="Times New Roman"/>
                         </a:rPr>
-                        <a:t>3,828</a:t>
+                        <a:t>3,512</a:t>
                       </a:r>
                       <a:br/>
                       <a:r>
@@ -16895,7 +16895,7 @@
                           </a:solidFill>
                           <a:latin typeface="Times New Roman"/>
                         </a:rPr>
-                        <a:t>Cr. 0.38</a:t>
+                        <a:t>Cr. 0.35</a:t>
                       </a:r>
                     </a:p>
                   </a:txBody>
@@ -16938,7 +16938,7 @@
                           </a:solidFill>
                           <a:latin typeface="Times New Roman"/>
                         </a:rPr>
-                        <a:t>172</a:t>
+                        <a:t>162</a:t>
                       </a:r>
                     </a:p>
                   </a:txBody>
@@ -17175,7 +17175,7 @@
                           </a:solidFill>
                           <a:latin typeface="Times New Roman"/>
                         </a:rPr>
-                        <a:t>102,694</a:t>
+                        <a:t>100,083</a:t>
                       </a:r>
                       <a:br/>
                       <a:r>
@@ -17185,7 +17185,7 @@
                           </a:solidFill>
                           <a:latin typeface="Times New Roman"/>
                         </a:rPr>
-                        <a:t>Cr. 10.27</a:t>
+                        <a:t>Cr. 10.01</a:t>
                       </a:r>
                     </a:p>
                   </a:txBody>
@@ -17281,7 +17281,7 @@
                           </a:solidFill>
                           <a:latin typeface="Times New Roman"/>
                         </a:rPr>
-                        <a:t>73,426</a:t>
+                        <a:t>76,037</a:t>
                       </a:r>
                       <a:br/>
                       <a:r>
@@ -17291,7 +17291,7 @@
                           </a:solidFill>
                           <a:latin typeface="Times New Roman"/>
                         </a:rPr>
-                        <a:t>Cr. 7.34</a:t>
+                        <a:t>Cr. 7.60</a:t>
                       </a:r>
                     </a:p>
                   </a:txBody>
@@ -17334,7 +17334,7 @@
                           </a:solidFill>
                           <a:latin typeface="Times New Roman"/>
                         </a:rPr>
-                        <a:t>172</a:t>
+                        <a:t>176</a:t>
                       </a:r>
                     </a:p>
                   </a:txBody>
@@ -17571,7 +17571,7 @@
                           </a:solidFill>
                           <a:latin typeface="Times New Roman"/>
                         </a:rPr>
-                        <a:t>126,473</a:t>
+                        <a:t>320,448</a:t>
                       </a:r>
                       <a:br/>
                       <a:r>
@@ -17581,7 +17581,7 @@
                           </a:solidFill>
                           <a:latin typeface="Times New Roman"/>
                         </a:rPr>
-                        <a:t>Cr. 12.65</a:t>
+                        <a:t>Cr. 32.04</a:t>
                       </a:r>
                     </a:p>
                   </a:txBody>
@@ -17677,7 +17677,7 @@
                           </a:solidFill>
                           <a:latin typeface="Times New Roman"/>
                         </a:rPr>
-                        <a:t>231,982</a:t>
+                        <a:t>38,007</a:t>
                       </a:r>
                       <a:br/>
                       <a:r>
@@ -17687,7 +17687,7 @@
                           </a:solidFill>
                           <a:latin typeface="Times New Roman"/>
                         </a:rPr>
-                        <a:t>Cr. 23.20</a:t>
+                        <a:t>Cr. 3.80</a:t>
                       </a:r>
                     </a:p>
                   </a:txBody>
@@ -17730,7 +17730,7 @@
                           </a:solidFill>
                           <a:latin typeface="Times New Roman"/>
                         </a:rPr>
-                        <a:t>283</a:t>
+                        <a:t>112</a:t>
                       </a:r>
                     </a:p>
                   </a:txBody>
@@ -17967,7 +17967,7 @@
                           </a:solidFill>
                           <a:latin typeface="Times New Roman"/>
                         </a:rPr>
-                        <a:t>4,854,516</a:t>
+                        <a:t>5,095,979</a:t>
                       </a:r>
                       <a:br/>
                       <a:r>
@@ -17977,7 +17977,7 @@
                           </a:solidFill>
                           <a:latin typeface="Times New Roman"/>
                         </a:rPr>
-                        <a:t>Cr. 485.45</a:t>
+                        <a:t>Cr. 509.60</a:t>
                       </a:r>
                     </a:p>
                   </a:txBody>
@@ -18073,7 +18073,7 @@
                           </a:solidFill>
                           <a:latin typeface="Times New Roman"/>
                         </a:rPr>
-                        <a:t>861,394</a:t>
+                        <a:t>619,931</a:t>
                       </a:r>
                       <a:br/>
                       <a:r>
@@ -18083,7 +18083,7 @@
                           </a:solidFill>
                           <a:latin typeface="Times New Roman"/>
                         </a:rPr>
-                        <a:t>Cr. 86.14</a:t>
+                        <a:t>Cr. 61.99</a:t>
                       </a:r>
                     </a:p>
                   </a:txBody>
@@ -18126,7 +18126,7 @@
                           </a:solidFill>
                           <a:latin typeface="Times New Roman"/>
                         </a:rPr>
-                        <a:t>118</a:t>
+                        <a:t>112</a:t>
                       </a:r>
                     </a:p>
                   </a:txBody>
@@ -18978,7 +18978,7 @@
                           </a:solidFill>
                           <a:latin typeface="Times New Roman"/>
                         </a:rPr>
-                        <a:t>356,251</a:t>
+                        <a:t>350,722</a:t>
                       </a:r>
                       <a:br/>
                       <a:r>
@@ -18988,7 +18988,7 @@
                           </a:solidFill>
                           <a:latin typeface="Times New Roman"/>
                         </a:rPr>
-                        <a:t>Cr. 35.63</a:t>
+                        <a:t>Cr. 35.07</a:t>
                       </a:r>
                     </a:p>
                   </a:txBody>
@@ -19084,7 +19084,7 @@
                           </a:solidFill>
                           <a:latin typeface="Times New Roman"/>
                         </a:rPr>
-                        <a:t>232,066</a:t>
+                        <a:t>237,595</a:t>
                       </a:r>
                       <a:br/>
                       <a:r>
@@ -19094,7 +19094,7 @@
                           </a:solidFill>
                           <a:latin typeface="Times New Roman"/>
                         </a:rPr>
-                        <a:t>Cr. 23.21</a:t>
+                        <a:t>Cr. 23.76</a:t>
                       </a:r>
                     </a:p>
                   </a:txBody>
@@ -19137,7 +19137,7 @@
                           </a:solidFill>
                           <a:latin typeface="Times New Roman"/>
                         </a:rPr>
-                        <a:t>165</a:t>
+                        <a:t>168</a:t>
                       </a:r>
                     </a:p>
                   </a:txBody>
@@ -19374,7 +19374,7 @@
                           </a:solidFill>
                           <a:latin typeface="Times New Roman"/>
                         </a:rPr>
-                        <a:t>49,982</a:t>
+                        <a:t>52,719</a:t>
                       </a:r>
                       <a:br/>
                       <a:r>
@@ -19384,7 +19384,7 @@
                           </a:solidFill>
                           <a:latin typeface="Times New Roman"/>
                         </a:rPr>
-                        <a:t>Cr. 5.00</a:t>
+                        <a:t>Cr. 5.27</a:t>
                       </a:r>
                     </a:p>
                   </a:txBody>
@@ -19480,7 +19480,7 @@
                           </a:solidFill>
                           <a:latin typeface="Times New Roman"/>
                         </a:rPr>
-                        <a:t>13,037</a:t>
+                        <a:t>10,300</a:t>
                       </a:r>
                       <a:br/>
                       <a:r>
@@ -19490,7 +19490,7 @@
                           </a:solidFill>
                           <a:latin typeface="Times New Roman"/>
                         </a:rPr>
-                        <a:t>Cr. 1.30</a:t>
+                        <a:t>Cr. 1.03</a:t>
                       </a:r>
                     </a:p>
                   </a:txBody>
@@ -19533,7 +19533,7 @@
                           </a:solidFill>
                           <a:latin typeface="Times New Roman"/>
                         </a:rPr>
-                        <a:t>126</a:t>
+                        <a:t>120</a:t>
                       </a:r>
                     </a:p>
                   </a:txBody>
@@ -19770,7 +19770,7 @@
                           </a:solidFill>
                           <a:latin typeface="Times New Roman"/>
                         </a:rPr>
-                        <a:t>1,292,908</a:t>
+                        <a:t>1,330,274</a:t>
                       </a:r>
                       <a:br/>
                       <a:r>
@@ -19780,7 +19780,7 @@
                           </a:solidFill>
                           <a:latin typeface="Times New Roman"/>
                         </a:rPr>
-                        <a:t>Cr. 129.29</a:t>
+                        <a:t>Cr. 133.03</a:t>
                       </a:r>
                     </a:p>
                   </a:txBody>
@@ -19876,7 +19876,7 @@
                           </a:solidFill>
                           <a:latin typeface="Times New Roman"/>
                         </a:rPr>
-                        <a:t>-192,688</a:t>
+                        <a:t>-230,054</a:t>
                       </a:r>
                       <a:br/>
                       <a:r>
@@ -19886,7 +19886,7 @@
                           </a:solidFill>
                           <a:latin typeface="Times New Roman"/>
                         </a:rPr>
-                        <a:t>Cr. -19.27</a:t>
+                        <a:t>Cr. -23.01</a:t>
                       </a:r>
                     </a:p>
                   </a:txBody>
@@ -19929,7 +19929,7 @@
                           </a:solidFill>
                           <a:latin typeface="Times New Roman"/>
                         </a:rPr>
-                        <a:t>85</a:t>
+                        <a:t>83</a:t>
                       </a:r>
                     </a:p>
                   </a:txBody>
@@ -20166,7 +20166,7 @@
                           </a:solidFill>
                           <a:latin typeface="Times New Roman"/>
                         </a:rPr>
-                        <a:t>1,084,770</a:t>
+                        <a:t>1,396,328</a:t>
                       </a:r>
                       <a:br/>
                       <a:r>
@@ -20176,7 +20176,7 @@
                           </a:solidFill>
                           <a:latin typeface="Times New Roman"/>
                         </a:rPr>
-                        <a:t>Cr. 108.48</a:t>
+                        <a:t>Cr. 139.63</a:t>
                       </a:r>
                     </a:p>
                   </a:txBody>
@@ -20272,7 +20272,7 @@
                           </a:solidFill>
                           <a:latin typeface="Times New Roman"/>
                         </a:rPr>
-                        <a:t>573,697</a:t>
+                        <a:t>262,139</a:t>
                       </a:r>
                       <a:br/>
                       <a:r>
@@ -20282,7 +20282,7 @@
                           </a:solidFill>
                           <a:latin typeface="Times New Roman"/>
                         </a:rPr>
-                        <a:t>Cr. 57.37</a:t>
+                        <a:t>Cr. 26.21</a:t>
                       </a:r>
                     </a:p>
                   </a:txBody>
@@ -20325,7 +20325,7 @@
                           </a:solidFill>
                           <a:latin typeface="Times New Roman"/>
                         </a:rPr>
-                        <a:t>153</a:t>
+                        <a:t>119</a:t>
                       </a:r>
                     </a:p>
                   </a:txBody>
@@ -20562,7 +20562,7 @@
                           </a:solidFill>
                           <a:latin typeface="Times New Roman"/>
                         </a:rPr>
-                        <a:t>1,567,785</a:t>
+                        <a:t>1,538,432</a:t>
                       </a:r>
                       <a:br/>
                       <a:r>
@@ -20572,7 +20572,7 @@
                           </a:solidFill>
                           <a:latin typeface="Times New Roman"/>
                         </a:rPr>
-                        <a:t>Cr. 156.78</a:t>
+                        <a:t>Cr. 153.84</a:t>
                       </a:r>
                     </a:p>
                   </a:txBody>
@@ -20668,7 +20668,7 @@
                           </a:solidFill>
                           <a:latin typeface="Times New Roman"/>
                         </a:rPr>
-                        <a:t>239,289</a:t>
+                        <a:t>268,642</a:t>
                       </a:r>
                       <a:br/>
                       <a:r>
@@ -20678,7 +20678,7 @@
                           </a:solidFill>
                           <a:latin typeface="Times New Roman"/>
                         </a:rPr>
-                        <a:t>Cr. 23.93</a:t>
+                        <a:t>Cr. 26.86</a:t>
                       </a:r>
                     </a:p>
                   </a:txBody>
@@ -20721,7 +20721,7 @@
                           </a:solidFill>
                           <a:latin typeface="Times New Roman"/>
                         </a:rPr>
-                        <a:t>115</a:t>
+                        <a:t>117</a:t>
                       </a:r>
                     </a:p>
                   </a:txBody>
@@ -20958,7 +20958,7 @@
                           </a:solidFill>
                           <a:latin typeface="Times New Roman"/>
                         </a:rPr>
-                        <a:t>4,351,696</a:t>
+                        <a:t>4,668,475</a:t>
                       </a:r>
                       <a:br/>
                       <a:r>
@@ -20968,7 +20968,7 @@
                           </a:solidFill>
                           <a:latin typeface="Times New Roman"/>
                         </a:rPr>
-                        <a:t>Cr. 435.17</a:t>
+                        <a:t>Cr. 466.85</a:t>
                       </a:r>
                     </a:p>
                   </a:txBody>
@@ -21064,7 +21064,7 @@
                           </a:solidFill>
                           <a:latin typeface="Times New Roman"/>
                         </a:rPr>
-                        <a:t>865,401</a:t>
+                        <a:t>548,622</a:t>
                       </a:r>
                       <a:br/>
                       <a:r>
@@ -21074,7 +21074,7 @@
                           </a:solidFill>
                           <a:latin typeface="Times New Roman"/>
                         </a:rPr>
-                        <a:t>Cr. 86.54</a:t>
+                        <a:t>Cr. 54.86</a:t>
                       </a:r>
                     </a:p>
                   </a:txBody>
@@ -21117,7 +21117,7 @@
                           </a:solidFill>
                           <a:latin typeface="Times New Roman"/>
                         </a:rPr>
-                        <a:t>120</a:t>
+                        <a:t>112</a:t>
                       </a:r>
                     </a:p>
                   </a:txBody>

</xml_diff>